<commit_message>
fix: demo is now working
</commit_message>
<xml_diff>
--- a/entregables/Presentacion_LasGrills_Hackathon7.pptx
+++ b/entregables/Presentacion_LasGrills_Hackathon7.pptx
@@ -114,25 +114,25 @@
   <p:extLst>
     <p:ext uri="{521415D9-36F7-43E2-AB2F-B90AF26B5E84}">
       <p14:sectionLst xmlns:p14="http://schemas.microsoft.com/office/powerpoint/2010/main">
-        <p14:section name="Planteamiento" id="{8bd94ccd-ccc6-9a65-79a2-d72e3b7db6fb}">
+        <p14:section name="Planteamiento" id="{c1b862b9-a8a4-1e34-50e7-b265ce40429b}">
           <p14:sldIdLst>
             <p14:sldId id="256"/>
             <p14:sldId id="257"/>
           </p14:sldIdLst>
         </p14:section>
-        <p14:section name="Diseño" id="{ee281d40-d8cb-bd46-7042-5c87de069faa}">
+        <p14:section name="Diseño" id="{0d085a51-c62d-f46d-6ccc-00bb7e4ae4aa}">
           <p14:sldIdLst>
             <p14:sldId id="258"/>
             <p14:sldId id="259"/>
           </p14:sldIdLst>
         </p14:section>
-        <p14:section name="Implementación" id="{c726c00c-bcde-3823-7e89-6bbc052ba643}">
+        <p14:section name="Implementación" id="{c879df92-1a76-61a8-d170-c60997312e6c}">
           <p14:sldIdLst>
             <p14:sldId id="260"/>
             <p14:sldId id="261"/>
           </p14:sldIdLst>
         </p14:section>
-        <p14:section name="Resultados" id="{4ee75d81-a59a-9d95-0efb-b15b3a69f637}">
+        <p14:section name="Resultados" id="{ae1f8a2f-3a47-b01b-0983-ddd8ae2ac371}">
           <p14:sldIdLst>
             <p14:sldId id="262"/>
             <p14:sldId id="263"/>
@@ -284,13 +284,13 @@
                 <c:ptCount val="4"/>
                 <c:lvl>
                   <c:pt idx="0">
-                    <c:v>A</c:v>
+                    <c:v>A ✗</c:v>
                   </c:pt>
                   <c:pt idx="1">
-                    <c:v>B</c:v>
+                    <c:v>B ✗</c:v>
                   </c:pt>
                   <c:pt idx="2">
-                    <c:v>C ✗</c:v>
+                    <c:v>C</c:v>
                   </c:pt>
                   <c:pt idx="3">
                     <c:v>H (sin LLM)</c:v>
@@ -306,13 +306,13 @@
                 <c:formatCode>General</c:formatCode>
                 <c:ptCount val="4"/>
                 <c:pt idx="0">
-                  <c:v>54.7</c:v>
+                  <c:v>46.5</c:v>
                 </c:pt>
                 <c:pt idx="1">
-                  <c:v>73.2</c:v>
+                  <c:v>41.3</c:v>
                 </c:pt>
                 <c:pt idx="2">
-                  <c:v>39.2</c:v>
+                  <c:v>49.2</c:v>
                 </c:pt>
                 <c:pt idx="3">
                   <c:v>100</c:v>
@@ -1204,7 +1204,7 @@
           <a:p>
             <a:r>
               <a:rPr lang="en-US" dirty="0"/>
-              <a:t>Groq limita los tokens por minuto por modelo: por eso Analista y Evaluador usan qwen3.8-27b (tool calls en paralelo) y Planificador y Decisor usan gpt-oss-120b (razonamiento y JSON estricto). Llama ya no estaba disponible en Groq: el gestor lo detecta y usa la cadena de respaldo. Recomendamos 3 o más keys para la demo.</a:t>
+              <a:t>Groq limita los tokens por minuto por modelo: el Analista usa qwen3.8-27b (tool calls en paralelo, respuestas cortas) y Planificador, Evaluador y Decisor usan gpt-oss-120b (razonamiento, JSON estricto y respuestas largas: qwen solo admite 1000 tokens de salida por minuto). Llama ya no estaba disponible en Groq: el gestor lo detecta y usa la cadena de respaldo. Recomendamos 3 o más keys para la demo.</a:t>
             </a:r>
             <a:endParaRPr lang="en-US" dirty="0"/>
           </a:p>
@@ -4345,7 +4345,7 @@
                 <a:ea typeface="Calibri" pitchFamily="34" charset="-122"/>
                 <a:cs typeface="Calibri" pitchFamily="34" charset="-120"/>
               </a:rPr>
-              <a:t>qwen3.8-27b · 2 tools</a:t>
+              <a:t>gpt-oss-120b · 2 tools</a:t>
             </a:r>
             <a:endParaRPr lang="en-US" sz="1800" dirty="0"/>
           </a:p>
@@ -6625,7 +6625,7 @@
                 <a:ea typeface="Cambria" pitchFamily="34" charset="-122"/>
                 <a:cs typeface="Cambria" pitchFamily="34" charset="-120"/>
               </a:rPr>
-              <a:t>31.1 mil tokens</a:t>
+              <a:t>36.1 mil tokens</a:t>
             </a:r>
             <a:endParaRPr lang="en-US" sz="2600" dirty="0"/>
           </a:p>
@@ -6642,7 +6642,7 @@
                 <a:ea typeface="Calibri" pitchFamily="34" charset="-122"/>
                 <a:cs typeface="Calibri" pitchFamily="34" charset="-120"/>
               </a:rPr>
-              <a:t>por corrida completa · 9 llamadas a la API · 2 modelos para repartir la cuota por minuto</a:t>
+              <a:t>por corrida completa · 10 llamadas a la API · 2 modelos para repartir la cuota por minuto</a:t>
             </a:r>
             <a:endParaRPr lang="en-US" sz="2600" dirty="0"/>
           </a:p>
@@ -7656,7 +7656,7 @@
                 <a:ea typeface="Calibri" pitchFamily="34" charset="-122"/>
                 <a:cs typeface="Calibri" pitchFamily="34" charset="-120"/>
               </a:rPr>
-              <a:t>Mejor propuesta de los agentes 73.2 vs H 100 puntos. Gana la regla simple: H funciona como red de seguridad.</a:t>
+              <a:t>Mejor propuesta de los agentes 49.2 vs H 100 puntos. Gana la regla simple: H funciona como red de seguridad.</a:t>
             </a:r>
             <a:endParaRPr lang="en-US" sz="1600" dirty="0"/>
           </a:p>
@@ -7761,7 +7761,7 @@
                 <a:ea typeface="Calibri" pitchFamily="34" charset="-122"/>
                 <a:cs typeface="Calibri" pitchFamily="34" charset="-120"/>
               </a:rPr>
-              <a:t>11 de 11 verificaciones OK; 0 críticas fallidas. Revisa que las cifras citadas existan en el simulador.</a:t>
+              <a:t>10 de 11 verificaciones OK; 0 críticas fallidas. Revisa que las cifras citadas existan en el simulador.</a:t>
             </a:r>
             <a:endParaRPr lang="en-US" sz="1600" dirty="0"/>
           </a:p>
@@ -7971,7 +7971,7 @@
                 <a:ea typeface="Calibri" pitchFamily="34" charset="-122"/>
                 <a:cs typeface="Calibri" pitchFamily="34" charset="-120"/>
               </a:rPr>
-              <a:t>1 replanificación(es); la auditoría marcó 7 problemas (incluidos errores del Decisor) y escaló a una persona.</a:t>
+              <a:t>1 replanificación(es); la auditoría marcó 4 problemas (incluidos errores del Decisor) y escaló a una persona.</a:t>
             </a:r>
             <a:endParaRPr lang="en-US" sz="1600" dirty="0"/>
           </a:p>

</xml_diff>

<commit_message>
docs: pptx to pdf
</commit_message>
<xml_diff>
--- a/entregables/Presentacion_LasGrills_Hackathon7.pptx
+++ b/entregables/Presentacion_LasGrills_Hackathon7.pptx
@@ -114,25 +114,25 @@
   <p:extLst>
     <p:ext uri="{521415D9-36F7-43E2-AB2F-B90AF26B5E84}">
       <p14:sectionLst xmlns:p14="http://schemas.microsoft.com/office/powerpoint/2010/main">
-        <p14:section name="Planteamiento" id="{c1b862b9-a8a4-1e34-50e7-b265ce40429b}">
+        <p14:section name="Planteamiento" id="{0d83c6dc-c5c6-2ce8-79ab-656e2ac6d5aa}">
           <p14:sldIdLst>
             <p14:sldId id="256"/>
             <p14:sldId id="257"/>
           </p14:sldIdLst>
         </p14:section>
-        <p14:section name="Diseño" id="{0d085a51-c62d-f46d-6ccc-00bb7e4ae4aa}">
+        <p14:section name="Diseño" id="{318f099a-018a-0471-c8bf-b7fceefdfaeb}">
           <p14:sldIdLst>
             <p14:sldId id="258"/>
             <p14:sldId id="259"/>
           </p14:sldIdLst>
         </p14:section>
-        <p14:section name="Implementación" id="{c879df92-1a76-61a8-d170-c60997312e6c}">
+        <p14:section name="Implementación" id="{230adcba-b32a-218a-2ad3-d6a2ce9ede3d}">
           <p14:sldIdLst>
             <p14:sldId id="260"/>
             <p14:sldId id="261"/>
           </p14:sldIdLst>
         </p14:section>
-        <p14:section name="Resultados" id="{ae1f8a2f-3a47-b01b-0983-ddd8ae2ac371}">
+        <p14:section name="Resultados" id="{1eb08872-9b5a-e780-e13a-1699a21c1a9d}">
           <p14:sldIdLst>
             <p14:sldId id="262"/>
             <p14:sldId id="263"/>
@@ -145,316 +145,6 @@
     </p:ext>
   </p:extLst>
 </p:presentation>
-</file>
-
-<file path=ppt/charts/chart1.xml><?xml version="1.0" encoding="utf-8"?>
-<c:chartSpace xmlns:c="http://schemas.openxmlformats.org/drawingml/2006/chart" xmlns:a="http://schemas.openxmlformats.org/drawingml/2006/main" xmlns:r="http://schemas.openxmlformats.org/officeDocument/2006/relationships">
-  <c:date1904 val="0"/>
-  <c:roundedCorners val="1"/>
-  <c:chart>
-    <c:title>
-      <c:tx>
-        <c:rich>
-          <a:bodyPr/>
-          <a:lstStyle/>
-          <a:p>
-            <a:pPr>
-              <a:defRPr sz="1400" b="0" i="0" u="none" strike="noStrike">
-                <a:solidFill>
-                  <a:srgbClr val="211F1C"/>
-                </a:solidFill>
-                <a:latin typeface="+mn-lt"/>
-              </a:defRPr>
-            </a:pPr>
-            <a:r>
-              <a:rPr sz="1400" b="0" i="0" u="none" strike="noStrike">
-                <a:solidFill>
-                  <a:srgbClr val="211F1C"/>
-                </a:solidFill>
-                <a:latin typeface="+mn-lt"/>
-              </a:rPr>
-              <a:t>Puntaje 0–100 con el objetivo del día: puntualidad</a:t>
-            </a:r>
-          </a:p>
-        </c:rich>
-      </c:tx>
-      <c:layout/>
-      <c:overlay val="0"/>
-    </c:title>
-    <c:autoTitleDeleted val="0"/>
-    <c:plotArea>
-      <c:layout/>
-      <c:barChart>
-        <c:barDir val="col"/>
-        <c:grouping val="clustered"/>
-        <c:varyColors val="0"/>
-        <c:ser>
-          <c:idx val="0"/>
-          <c:order val="0"/>
-          <c:tx>
-            <c:strRef>
-              <c:f>Sheet1!$B$1</c:f>
-              <c:strCache>
-                <c:ptCount val="1"/>
-                <c:pt idx="0">
-                  <c:v>Puntaje</c:v>
-                </c:pt>
-              </c:strCache>
-            </c:strRef>
-          </c:tx>
-          <c:spPr>
-            <a:solidFill>
-              <a:srgbClr val="C9C6BF"/>
-            </a:solidFill>
-            <a:effectLst/>
-          </c:spPr>
-          <c:invertIfNegative val="0"/>
-          <c:dLbls>
-            <c:numFmt formatCode="0.0" sourceLinked="0"/>
-            <c:txPr>
-              <a:bodyPr/>
-              <a:lstStyle/>
-              <a:p>
-                <a:pPr>
-                  <a:defRPr b="0" i="0" strike="noStrike" sz="1200" u="none">
-                    <a:solidFill>
-                      <a:srgbClr val="211F1C"/>
-                    </a:solidFill>
-                    <a:latin typeface="+mn-lt"/>
-                  </a:defRPr>
-                </a:pPr>
-              </a:p>
-            </c:txPr>
-            <c:showLegendKey val="0"/>
-            <c:showVal val="1"/>
-            <c:showCatName val="0"/>
-            <c:showSerName val="0"/>
-            <c:showPercent val="0"/>
-            <c:showBubbleSize val="0"/>
-            <c:showLeaderLines val="0"/>
-          </c:dLbls>
-          <c:dPt>
-            <c:idx val="0"/>
-            <c:invertIfNegative val="0"/>
-            <c:bubble3D val="0"/>
-            <c:spPr>
-              <a:solidFill>
-                <a:srgbClr val="C9C6BF"/>
-              </a:solidFill>
-              <a:effectLst/>
-            </c:spPr>
-          </c:dPt>
-          <c:dPt>
-            <c:idx val="1"/>
-            <c:invertIfNegative val="0"/>
-            <c:bubble3D val="0"/>
-            <c:spPr>
-              <a:solidFill>
-                <a:srgbClr val="C9C6BF"/>
-              </a:solidFill>
-              <a:effectLst/>
-            </c:spPr>
-          </c:dPt>
-          <c:dPt>
-            <c:idx val="2"/>
-            <c:invertIfNegative val="0"/>
-            <c:bubble3D val="0"/>
-            <c:spPr>
-              <a:solidFill>
-                <a:srgbClr val="C9C6BF"/>
-              </a:solidFill>
-              <a:effectLst/>
-            </c:spPr>
-          </c:dPt>
-          <c:dPt>
-            <c:idx val="3"/>
-            <c:invertIfNegative val="0"/>
-            <c:bubble3D val="0"/>
-            <c:spPr>
-              <a:solidFill>
-                <a:srgbClr val="E8590C"/>
-              </a:solidFill>
-              <a:effectLst/>
-            </c:spPr>
-          </c:dPt>
-          <c:cat>
-            <c:multiLvlStrRef>
-              <c:f>Sheet1!$A$2:$A$5</c:f>
-              <c:multiLvlStrCache>
-                <c:ptCount val="4"/>
-                <c:lvl>
-                  <c:pt idx="0">
-                    <c:v>A ✗</c:v>
-                  </c:pt>
-                  <c:pt idx="1">
-                    <c:v>B ✗</c:v>
-                  </c:pt>
-                  <c:pt idx="2">
-                    <c:v>C</c:v>
-                  </c:pt>
-                  <c:pt idx="3">
-                    <c:v>H (sin LLM)</c:v>
-                  </c:pt>
-                </c:lvl>
-              </c:multiLvlStrCache>
-            </c:multiLvlStrRef>
-          </c:cat>
-          <c:val>
-            <c:numRef>
-              <c:f>Sheet1!$B$2:$B$5</c:f>
-              <c:numCache>
-                <c:formatCode>General</c:formatCode>
-                <c:ptCount val="4"/>
-                <c:pt idx="0">
-                  <c:v>46.5</c:v>
-                </c:pt>
-                <c:pt idx="1">
-                  <c:v>41.3</c:v>
-                </c:pt>
-                <c:pt idx="2">
-                  <c:v>49.2</c:v>
-                </c:pt>
-                <c:pt idx="3">
-                  <c:v>100</c:v>
-                </c:pt>
-              </c:numCache>
-            </c:numRef>
-          </c:val>
-        </c:ser>
-        <c:dLbls>
-          <c:numFmt formatCode="0.0" sourceLinked="0"/>
-          <c:txPr>
-            <a:bodyPr/>
-            <a:lstStyle/>
-            <a:p>
-              <a:pPr>
-                <a:defRPr b="0" i="0" strike="noStrike" sz="1200" u="none">
-                  <a:solidFill>
-                    <a:srgbClr val="211F1C"/>
-                  </a:solidFill>
-                  <a:latin typeface="+mn-lt"/>
-                </a:defRPr>
-              </a:pPr>
-            </a:p>
-          </c:txPr>
-          <c:showLegendKey val="0"/>
-          <c:showVal val="1"/>
-          <c:showCatName val="0"/>
-          <c:showSerName val="0"/>
-          <c:showPercent val="0"/>
-          <c:showBubbleSize val="0"/>
-          <c:showLeaderLines val="0"/>
-        </c:dLbls>
-        <c:gapWidth val="70"/>
-        <c:overlap val="0"/>
-        <c:axId val="2094734554"/>
-        <c:axId val="2094734552"/>
-        <c:axId val="2094734556"/>
-      </c:barChart>
-      <c:catAx>
-        <c:axId val="2094734554"/>
-        <c:scaling>
-          <c:orientation val="minMax"/>
-        </c:scaling>
-        <c:delete val="0"/>
-        <c:axPos val="b"/>
-        <c:numFmt formatCode="General" sourceLinked="1"/>
-        <c:majorTickMark val="out"/>
-        <c:minorTickMark val="none"/>
-        <c:tickLblPos val="low"/>
-        <c:spPr>
-          <a:ln w="12700" cap="flat">
-            <a:solidFill>
-              <a:srgbClr val="888888"/>
-            </a:solidFill>
-            <a:prstDash val="solid"/>
-            <a:round/>
-          </a:ln>
-        </c:spPr>
-        <c:txPr>
-          <a:bodyPr/>
-          <a:lstStyle/>
-          <a:p>
-            <a:pPr>
-              <a:defRPr sz="1200" b="0" i="0" u="none" strike="noStrike">
-                <a:solidFill>
-                  <a:srgbClr val="5B5954"/>
-                </a:solidFill>
-                <a:latin typeface="+mn-lt"/>
-              </a:defRPr>
-            </a:pPr>
-            <a:endParaRPr lang="en-US"/>
-          </a:p>
-        </c:txPr>
-        <c:crossAx val="2094734552"/>
-        <c:crosses val="autoZero"/>
-        <c:auto val="1"/>
-        <c:lblAlgn val="ctr"/>
-        <c:noMultiLvlLbl val="1"/>
-      </c:catAx>
-      <c:valAx>
-        <c:axId val="2094734552"/>
-        <c:scaling>
-          <c:orientation val="minMax"/>
-          <c:max val="100"/>
-          <c:min val="0"/>
-        </c:scaling>
-        <c:delete val="1"/>
-        <c:axPos val="l"/>
-        <c:numFmt formatCode="General" sourceLinked="0"/>
-        <c:majorTickMark val="out"/>
-        <c:minorTickMark val="none"/>
-        <c:tickLblPos val="nextTo"/>
-        <c:spPr>
-          <a:ln w="12700" cap="flat">
-            <a:solidFill>
-              <a:srgbClr val="888888"/>
-            </a:solidFill>
-            <a:prstDash val="solid"/>
-            <a:round/>
-          </a:ln>
-        </c:spPr>
-        <c:txPr>
-          <a:bodyPr/>
-          <a:lstStyle/>
-          <a:p>
-            <a:pPr>
-              <a:defRPr sz="1200" b="0" i="0" u="none" strike="noStrike">
-                <a:solidFill>
-                  <a:srgbClr val="000000"/>
-                </a:solidFill>
-                <a:latin typeface="Arial"/>
-              </a:defRPr>
-            </a:pPr>
-            <a:endParaRPr lang="en-US"/>
-          </a:p>
-        </c:txPr>
-        <c:crossAx val="2094734554"/>
-        <c:crosses val="autoZero"/>
-        <c:crossBetween val="between"/>
-      </c:valAx>
-      <c:spPr>
-        <a:noFill/>
-        <a:ln>
-          <a:noFill/>
-        </a:ln>
-        <a:effectLst/>
-      </c:spPr>
-    </c:plotArea>
-    <c:plotVisOnly val="1"/>
-    <c:dispBlanksAs val="span"/>
-  </c:chart>
-  <c:spPr>
-    <a:noFill/>
-    <a:ln>
-      <a:noFill/>
-    </a:ln>
-    <a:effectLst/>
-  </c:spPr>
-  <c:externalData r:id="rId1">
-    <c:autoUpdate val="0"/>
-  </c:externalData>
-</c:chartSpace>
 </file>
 
 <file path=ppt/notesMasters/notesMaster1.xml><?xml version="1.0" encoding="utf-8"?>
@@ -1592,9 +1282,9 @@
                 <a:solidFill>
                   <a:schemeClr val="bg1"/>
                 </a:solidFill>
-                <a:latin typeface="Cambria" pitchFamily="34" charset="0"/>
-                <a:ea typeface="Cambria" pitchFamily="34" charset="-122"/>
-                <a:cs typeface="Cambria" pitchFamily="34" charset="-120"/>
+                <a:latin typeface="Georgia" pitchFamily="34" charset="0"/>
+                <a:ea typeface="Georgia" pitchFamily="34" charset="-122"/>
+                <a:cs typeface="Georgia" pitchFamily="34" charset="-120"/>
               </a:defRPr>
             </a:lvl1pPr>
           </a:lstStyle>
@@ -1634,9 +1324,9 @@
                 <a:solidFill>
                   <a:schemeClr val="accent6"/>
                 </a:solidFill>
-                <a:latin typeface="Calibri" pitchFamily="34" charset="0"/>
-                <a:ea typeface="Calibri" pitchFamily="34" charset="-122"/>
-                <a:cs typeface="Calibri" pitchFamily="34" charset="-120"/>
+                <a:latin typeface="Arial" pitchFamily="34" charset="0"/>
+                <a:ea typeface="Arial" pitchFamily="34" charset="-122"/>
+                <a:cs typeface="Arial" pitchFamily="34" charset="-120"/>
               </a:defRPr>
             </a:lvl1pPr>
           </a:lstStyle>
@@ -1708,9 +1398,9 @@
                 <a:solidFill>
                   <a:schemeClr val="tx1"/>
                 </a:solidFill>
-                <a:latin typeface="Cambria" pitchFamily="34" charset="0"/>
-                <a:ea typeface="Cambria" pitchFamily="34" charset="-122"/>
-                <a:cs typeface="Cambria" pitchFamily="34" charset="-120"/>
+                <a:latin typeface="Georgia" pitchFamily="34" charset="0"/>
+                <a:ea typeface="Georgia" pitchFamily="34" charset="-122"/>
+                <a:cs typeface="Georgia" pitchFamily="34" charset="-120"/>
               </a:defRPr>
             </a:lvl1pPr>
           </a:lstStyle>
@@ -1751,9 +1441,9 @@
                 <a:solidFill>
                   <a:schemeClr val="tx2"/>
                 </a:solidFill>
-                <a:latin typeface="Calibri" pitchFamily="34" charset="0"/>
-                <a:ea typeface="Calibri" pitchFamily="34" charset="-122"/>
-                <a:cs typeface="Calibri" pitchFamily="34" charset="-120"/>
+                <a:latin typeface="Arial" pitchFamily="34" charset="0"/>
+                <a:ea typeface="Arial" pitchFamily="34" charset="-122"/>
+                <a:cs typeface="Arial" pitchFamily="34" charset="-120"/>
               </a:rPr>
               <a:t>Las Grills · Hackathon 7 · RutaBrasa</a:t>
             </a:r>
@@ -1866,9 +1556,9 @@
                 <a:solidFill>
                   <a:schemeClr val="bg1"/>
                 </a:solidFill>
-                <a:latin typeface="Cambria" pitchFamily="34" charset="0"/>
-                <a:ea typeface="Cambria" pitchFamily="34" charset="-122"/>
-                <a:cs typeface="Cambria" pitchFamily="34" charset="-120"/>
+                <a:latin typeface="Georgia" pitchFamily="34" charset="0"/>
+                <a:ea typeface="Georgia" pitchFamily="34" charset="-122"/>
+                <a:cs typeface="Georgia" pitchFamily="34" charset="-120"/>
               </a:defRPr>
             </a:lvl1pPr>
           </a:lstStyle>
@@ -1909,9 +1599,9 @@
                 <a:solidFill>
                   <a:schemeClr val="accent6"/>
                 </a:solidFill>
-                <a:latin typeface="Calibri" pitchFamily="34" charset="0"/>
-                <a:ea typeface="Calibri" pitchFamily="34" charset="-122"/>
-                <a:cs typeface="Calibri" pitchFamily="34" charset="-120"/>
+                <a:latin typeface="Arial" pitchFamily="34" charset="0"/>
+                <a:ea typeface="Arial" pitchFamily="34" charset="-122"/>
+                <a:cs typeface="Arial" pitchFamily="34" charset="-120"/>
               </a:rPr>
               <a:t>Las Grills · Hackathon 7 · RutaBrasa</a:t>
             </a:r>
@@ -2345,9 +2035,9 @@
                 <a:solidFill>
                   <a:schemeClr val="bg1"/>
                 </a:solidFill>
-                <a:latin typeface="Cambria" pitchFamily="34" charset="0"/>
-                <a:ea typeface="Cambria" pitchFamily="34" charset="-122"/>
-                <a:cs typeface="Cambria" pitchFamily="34" charset="-120"/>
+                <a:latin typeface="Georgia" pitchFamily="34" charset="0"/>
+                <a:ea typeface="Georgia" pitchFamily="34" charset="-122"/>
+                <a:cs typeface="Georgia" pitchFamily="34" charset="-120"/>
               </a:rPr>
               <a:t>RutaBrasa</a:t>
             </a:r>
@@ -2386,9 +2076,9 @@
                 <a:solidFill>
                   <a:schemeClr val="accent6"/>
                 </a:solidFill>
-                <a:latin typeface="Calibri" pitchFamily="34" charset="0"/>
-                <a:ea typeface="Calibri" pitchFamily="34" charset="-122"/>
-                <a:cs typeface="Calibri" pitchFamily="34" charset="-120"/>
+                <a:latin typeface="Arial" pitchFamily="34" charset="0"/>
+                <a:ea typeface="Arial" pitchFamily="34" charset="-122"/>
+                <a:cs typeface="Arial" pitchFamily="34" charset="-120"/>
               </a:rPr>
               <a:t>Sistema multi-agente con Groq para planificar el reparto de una distribuidora en Lima</a:t>
             </a:r>
@@ -2425,9 +2115,9 @@
                 <a:solidFill>
                   <a:schemeClr val="bg1"/>
                 </a:solidFill>
-                <a:latin typeface="Calibri" pitchFamily="34" charset="0"/>
-                <a:ea typeface="Calibri" pitchFamily="34" charset="-122"/>
-                <a:cs typeface="Calibri" pitchFamily="34" charset="-120"/>
+                <a:latin typeface="Arial" pitchFamily="34" charset="0"/>
+                <a:ea typeface="Arial" pitchFamily="34" charset="-122"/>
+                <a:cs typeface="Arial" pitchFamily="34" charset="-120"/>
               </a:rPr>
               <a:t>Las Grills · Caso 3: Planificador logístico</a:t>
             </a:r>
@@ -2442,9 +2132,9 @@
                 <a:solidFill>
                   <a:schemeClr val="bg1"/>
                 </a:solidFill>
-                <a:latin typeface="Calibri" pitchFamily="34" charset="0"/>
-                <a:ea typeface="Calibri" pitchFamily="34" charset="-122"/>
-                <a:cs typeface="Calibri" pitchFamily="34" charset="-120"/>
+                <a:latin typeface="Arial" pitchFamily="34" charset="0"/>
+                <a:ea typeface="Arial" pitchFamily="34" charset="-122"/>
+                <a:cs typeface="Arial" pitchFamily="34" charset="-120"/>
               </a:rPr>
               <a:t>Jimena Gurbillon · Maria Surco · Nayeli Guzman · Bihonda Epiquien · Andrea Coa</a:t>
             </a:r>
@@ -2459,9 +2149,9 @@
                 <a:solidFill>
                   <a:schemeClr val="bg1"/>
                 </a:solidFill>
-                <a:latin typeface="Calibri" pitchFamily="34" charset="0"/>
-                <a:ea typeface="Calibri" pitchFamily="34" charset="-122"/>
-                <a:cs typeface="Calibri" pitchFamily="34" charset="-120"/>
+                <a:latin typeface="Arial" pitchFamily="34" charset="0"/>
+                <a:ea typeface="Arial" pitchFamily="34" charset="-122"/>
+                <a:cs typeface="Arial" pitchFamily="34" charset="-120"/>
               </a:rPr>
               <a:t>Hackathon 7 · Planificación y Toma de Decisiones en IA · UTEC · 14 de octubre de 2026</a:t>
             </a:r>
@@ -2574,9 +2264,9 @@
                 <a:solidFill>
                   <a:schemeClr val="tx1"/>
                 </a:solidFill>
-                <a:latin typeface="Cambria" pitchFamily="34" charset="0"/>
-                <a:ea typeface="Cambria" pitchFamily="34" charset="-122"/>
-                <a:cs typeface="Cambria" pitchFamily="34" charset="-120"/>
+                <a:latin typeface="Georgia" pitchFamily="34" charset="0"/>
+                <a:ea typeface="Georgia" pitchFamily="34" charset="-122"/>
+                <a:cs typeface="Georgia" pitchFamily="34" charset="-120"/>
               </a:rPr>
               <a:t>El problema: cada mañana, ~19 pedidos y 5 vehículos</a:t>
             </a:r>
@@ -2662,9 +2352,9 @@
                 <a:solidFill>
                   <a:schemeClr val="tx1"/>
                 </a:solidFill>
-                <a:latin typeface="Calibri" pitchFamily="34" charset="0"/>
-                <a:ea typeface="Calibri" pitchFamily="34" charset="-122"/>
-                <a:cs typeface="Calibri" pitchFamily="34" charset="-120"/>
+                <a:latin typeface="Arial" pitchFamily="34" charset="0"/>
+                <a:ea typeface="Arial" pitchFamily="34" charset="-122"/>
+                <a:cs typeface="Arial" pitchFamily="34" charset="-120"/>
               </a:rPr>
               <a:t>Contexto</a:t>
             </a:r>
@@ -2679,9 +2369,9 @@
                 <a:solidFill>
                   <a:schemeClr val="tx2"/>
                 </a:solidFill>
-                <a:latin typeface="Calibri" pitchFamily="34" charset="0"/>
-                <a:ea typeface="Calibri" pitchFamily="34" charset="-122"/>
-                <a:cs typeface="Calibri" pitchFamily="34" charset="-120"/>
+                <a:latin typeface="Arial" pitchFamily="34" charset="0"/>
+                <a:ea typeface="Arial" pitchFamily="34" charset="-122"/>
+                <a:cs typeface="Arial" pitchFamily="34" charset="-120"/>
               </a:rPr>
               <a:t>Distribuidora (ficticia) en Surquillo que abastece a pollerías y parrillas con carne refrigerada, carbón y abarrotes.</a:t>
             </a:r>
@@ -2767,9 +2457,9 @@
                 <a:solidFill>
                   <a:schemeClr val="tx1"/>
                 </a:solidFill>
-                <a:latin typeface="Calibri" pitchFamily="34" charset="0"/>
-                <a:ea typeface="Calibri" pitchFamily="34" charset="-122"/>
-                <a:cs typeface="Calibri" pitchFamily="34" charset="-120"/>
+                <a:latin typeface="Arial" pitchFamily="34" charset="0"/>
+                <a:ea typeface="Arial" pitchFamily="34" charset="-122"/>
+                <a:cs typeface="Arial" pitchFamily="34" charset="-120"/>
               </a:rPr>
               <a:t>Decisión a apoyar</a:t>
             </a:r>
@@ -2784,9 +2474,9 @@
                 <a:solidFill>
                   <a:schemeClr val="tx2"/>
                 </a:solidFill>
-                <a:latin typeface="Calibri" pitchFamily="34" charset="0"/>
-                <a:ea typeface="Calibri" pitchFamily="34" charset="-122"/>
-                <a:cs typeface="Calibri" pitchFamily="34" charset="-120"/>
+                <a:latin typeface="Arial" pitchFamily="34" charset="0"/>
+                <a:ea typeface="Arial" pitchFamily="34" charset="-122"/>
+                <a:cs typeface="Arial" pitchFamily="34" charset="-120"/>
               </a:rPr>
               <a:t>Qué vehículo lleva cada pedido, en qué orden y si alguno hace una segunda vuelta.</a:t>
             </a:r>
@@ -2872,9 +2562,9 @@
                 <a:solidFill>
                   <a:schemeClr val="tx1"/>
                 </a:solidFill>
-                <a:latin typeface="Calibri" pitchFamily="34" charset="0"/>
-                <a:ea typeface="Calibri" pitchFamily="34" charset="-122"/>
-                <a:cs typeface="Calibri" pitchFamily="34" charset="-120"/>
+                <a:latin typeface="Arial" pitchFamily="34" charset="0"/>
+                <a:ea typeface="Arial" pitchFamily="34" charset="-122"/>
+                <a:cs typeface="Arial" pitchFamily="34" charset="-120"/>
               </a:rPr>
               <a:t>Usuario</a:t>
             </a:r>
@@ -2889,9 +2579,9 @@
                 <a:solidFill>
                   <a:schemeClr val="tx2"/>
                 </a:solidFill>
-                <a:latin typeface="Calibri" pitchFamily="34" charset="0"/>
-                <a:ea typeface="Calibri" pitchFamily="34" charset="-122"/>
-                <a:cs typeface="Calibri" pitchFamily="34" charset="-120"/>
+                <a:latin typeface="Arial" pitchFamily="34" charset="0"/>
+                <a:ea typeface="Arial" pitchFamily="34" charset="-122"/>
+                <a:cs typeface="Arial" pitchFamily="34" charset="-120"/>
               </a:rPr>
               <a:t>El jefe de despacho aprueba; choferes y área comercial usan las hojas de ruta y las ETA.</a:t>
             </a:r>
@@ -2977,9 +2667,9 @@
                 <a:solidFill>
                   <a:schemeClr val="tx1"/>
                 </a:solidFill>
-                <a:latin typeface="Calibri" pitchFamily="34" charset="0"/>
-                <a:ea typeface="Calibri" pitchFamily="34" charset="-122"/>
-                <a:cs typeface="Calibri" pitchFamily="34" charset="-120"/>
+                <a:latin typeface="Arial" pitchFamily="34" charset="0"/>
+                <a:ea typeface="Arial" pitchFamily="34" charset="-122"/>
+                <a:cs typeface="Arial" pitchFamily="34" charset="-120"/>
               </a:rPr>
               <a:t>Impacto</a:t>
             </a:r>
@@ -2994,9 +2684,9 @@
                 <a:solidFill>
                   <a:schemeClr val="tx2"/>
                 </a:solidFill>
-                <a:latin typeface="Calibri" pitchFamily="34" charset="0"/>
-                <a:ea typeface="Calibri" pitchFamily="34" charset="-122"/>
-                <a:cs typeface="Calibri" pitchFamily="34" charset="-120"/>
+                <a:latin typeface="Arial" pitchFamily="34" charset="0"/>
+                <a:ea typeface="Arial" pitchFamily="34" charset="-122"/>
+                <a:cs typeface="Arial" pitchFamily="34" charset="-120"/>
               </a:rPr>
               <a:t>Planificar en ~2 min en vez de ~45 y saber antes de salir qué pedidos no se van a cumplir.</a:t>
             </a:r>
@@ -3060,9 +2750,9 @@
                 <a:solidFill>
                   <a:schemeClr val="accent1"/>
                 </a:solidFill>
-                <a:latin typeface="Cambria" pitchFamily="34" charset="0"/>
-                <a:ea typeface="Cambria" pitchFamily="34" charset="-122"/>
-                <a:cs typeface="Cambria" pitchFamily="34" charset="-120"/>
+                <a:latin typeface="Georgia" pitchFamily="34" charset="0"/>
+                <a:ea typeface="Georgia" pitchFamily="34" charset="-122"/>
+                <a:cs typeface="Georgia" pitchFamily="34" charset="-120"/>
               </a:rPr>
               <a:t>×1.7</a:t>
             </a:r>
@@ -3077,9 +2767,9 @@
                 <a:solidFill>
                   <a:schemeClr val="tx2"/>
                 </a:solidFill>
-                <a:latin typeface="Calibri" pitchFamily="34" charset="0"/>
-                <a:ea typeface="Calibri" pitchFamily="34" charset="-122"/>
-                <a:cs typeface="Calibri" pitchFamily="34" charset="-120"/>
+                <a:latin typeface="Arial" pitchFamily="34" charset="0"/>
+                <a:ea typeface="Arial" pitchFamily="34" charset="-122"/>
+                <a:cs typeface="Arial" pitchFamily="34" charset="-120"/>
               </a:rPr>
               <a:t>tiempo de viaje en hora punta (7:00–10:00)</a:t>
             </a:r>
@@ -3143,9 +2833,9 @@
                 <a:solidFill>
                   <a:schemeClr val="accent1"/>
                 </a:solidFill>
-                <a:latin typeface="Cambria" pitchFamily="34" charset="0"/>
-                <a:ea typeface="Cambria" pitchFamily="34" charset="-122"/>
-                <a:cs typeface="Cambria" pitchFamily="34" charset="-120"/>
+                <a:latin typeface="Georgia" pitchFamily="34" charset="0"/>
+                <a:ea typeface="Georgia" pitchFamily="34" charset="-122"/>
+                <a:cs typeface="Georgia" pitchFamily="34" charset="-120"/>
               </a:rPr>
               <a:t>73%</a:t>
             </a:r>
@@ -3160,9 +2850,9 @@
                 <a:solidFill>
                   <a:schemeClr val="tx2"/>
                 </a:solidFill>
-                <a:latin typeface="Calibri" pitchFamily="34" charset="0"/>
-                <a:ea typeface="Calibri" pitchFamily="34" charset="-122"/>
-                <a:cs typeface="Calibri" pitchFamily="34" charset="-120"/>
+                <a:latin typeface="Arial" pitchFamily="34" charset="0"/>
+                <a:ea typeface="Arial" pitchFamily="34" charset="-122"/>
+                <a:cs typeface="Arial" pitchFamily="34" charset="-120"/>
               </a:rPr>
               <a:t>de la carga es refrigerada: cadena de frío</a:t>
             </a:r>
@@ -3226,9 +2916,9 @@
                 <a:solidFill>
                   <a:schemeClr val="accent1"/>
                 </a:solidFill>
-                <a:latin typeface="Cambria" pitchFamily="34" charset="0"/>
-                <a:ea typeface="Cambria" pitchFamily="34" charset="-122"/>
-                <a:cs typeface="Cambria" pitchFamily="34" charset="-120"/>
+                <a:latin typeface="Georgia" pitchFamily="34" charset="0"/>
+                <a:ea typeface="Georgia" pitchFamily="34" charset="-122"/>
+                <a:cs typeface="Georgia" pitchFamily="34" charset="-120"/>
               </a:rPr>
               <a:t>8:00–12:30</a:t>
             </a:r>
@@ -3243,9 +2933,9 @@
                 <a:solidFill>
                   <a:schemeClr val="tx2"/>
                 </a:solidFill>
-                <a:latin typeface="Calibri" pitchFamily="34" charset="0"/>
-                <a:ea typeface="Calibri" pitchFamily="34" charset="-122"/>
-                <a:cs typeface="Calibri" pitchFamily="34" charset="-120"/>
+                <a:latin typeface="Arial" pitchFamily="34" charset="0"/>
+                <a:ea typeface="Arial" pitchFamily="34" charset="-122"/>
+                <a:cs typeface="Arial" pitchFamily="34" charset="-120"/>
               </a:rPr>
               <a:t>ventanas de recepción, antes del almuerzo</a:t>
             </a:r>
@@ -3282,9 +2972,9 @@
                 <a:solidFill>
                   <a:schemeClr val="tx1"/>
                 </a:solidFill>
-                <a:latin typeface="Calibri" pitchFamily="34" charset="0"/>
-                <a:ea typeface="Calibri" pitchFamily="34" charset="-122"/>
-                <a:cs typeface="Calibri" pitchFamily="34" charset="-120"/>
+                <a:latin typeface="Arial" pitchFamily="34" charset="0"/>
+                <a:ea typeface="Arial" pitchFamily="34" charset="-122"/>
+                <a:cs typeface="Arial" pitchFamily="34" charset="-120"/>
               </a:rPr>
               <a:t>Criterios:</a:t>
             </a:r>
@@ -3348,9 +3038,9 @@
                 <a:solidFill>
                   <a:schemeClr val="bg1"/>
                 </a:solidFill>
-                <a:latin typeface="Calibri" pitchFamily="34" charset="0"/>
-                <a:ea typeface="Calibri" pitchFamily="34" charset="-122"/>
-                <a:cs typeface="Calibri" pitchFamily="34" charset="-120"/>
+                <a:latin typeface="Arial" pitchFamily="34" charset="0"/>
+                <a:ea typeface="Arial" pitchFamily="34" charset="-122"/>
+                <a:cs typeface="Arial" pitchFamily="34" charset="-120"/>
               </a:rPr>
               <a:t>Factibilidad (dura)</a:t>
             </a:r>
@@ -3414,9 +3104,9 @@
                 <a:solidFill>
                   <a:schemeClr val="tx1"/>
                 </a:solidFill>
-                <a:latin typeface="Calibri" pitchFamily="34" charset="0"/>
-                <a:ea typeface="Calibri" pitchFamily="34" charset="-122"/>
-                <a:cs typeface="Calibri" pitchFamily="34" charset="-120"/>
+                <a:latin typeface="Arial" pitchFamily="34" charset="0"/>
+                <a:ea typeface="Arial" pitchFamily="34" charset="-122"/>
+                <a:cs typeface="Arial" pitchFamily="34" charset="-120"/>
               </a:rPr>
               <a:t>Puntualidad</a:t>
             </a:r>
@@ -3480,9 +3170,9 @@
                 <a:solidFill>
                   <a:schemeClr val="tx1"/>
                 </a:solidFill>
-                <a:latin typeface="Calibri" pitchFamily="34" charset="0"/>
-                <a:ea typeface="Calibri" pitchFamily="34" charset="-122"/>
-                <a:cs typeface="Calibri" pitchFamily="34" charset="-120"/>
+                <a:latin typeface="Arial" pitchFamily="34" charset="0"/>
+                <a:ea typeface="Arial" pitchFamily="34" charset="-122"/>
+                <a:cs typeface="Arial" pitchFamily="34" charset="-120"/>
               </a:rPr>
               <a:t>Costo</a:t>
             </a:r>
@@ -3546,9 +3236,9 @@
                 <a:solidFill>
                   <a:schemeClr val="tx1"/>
                 </a:solidFill>
-                <a:latin typeface="Calibri" pitchFamily="34" charset="0"/>
-                <a:ea typeface="Calibri" pitchFamily="34" charset="-122"/>
-                <a:cs typeface="Calibri" pitchFamily="34" charset="-120"/>
+                <a:latin typeface="Arial" pitchFamily="34" charset="0"/>
+                <a:ea typeface="Arial" pitchFamily="34" charset="-122"/>
+                <a:cs typeface="Arial" pitchFamily="34" charset="-120"/>
               </a:rPr>
               <a:t>Tiempo total</a:t>
             </a:r>
@@ -3612,9 +3302,9 @@
                 <a:solidFill>
                   <a:schemeClr val="tx1"/>
                 </a:solidFill>
-                <a:latin typeface="Calibri" pitchFamily="34" charset="0"/>
-                <a:ea typeface="Calibri" pitchFamily="34" charset="-122"/>
-                <a:cs typeface="Calibri" pitchFamily="34" charset="-120"/>
+                <a:latin typeface="Arial" pitchFamily="34" charset="0"/>
+                <a:ea typeface="Arial" pitchFamily="34" charset="-122"/>
+                <a:cs typeface="Arial" pitchFamily="34" charset="-120"/>
               </a:rPr>
               <a:t>Robustez</a:t>
             </a:r>
@@ -3678,9 +3368,9 @@
                 <a:solidFill>
                   <a:schemeClr val="tx1"/>
                 </a:solidFill>
-                <a:latin typeface="Calibri" pitchFamily="34" charset="0"/>
-                <a:ea typeface="Calibri" pitchFamily="34" charset="-122"/>
-                <a:cs typeface="Calibri" pitchFamily="34" charset="-120"/>
+                <a:latin typeface="Arial" pitchFamily="34" charset="0"/>
+                <a:ea typeface="Arial" pitchFamily="34" charset="-122"/>
+                <a:cs typeface="Arial" pitchFamily="34" charset="-120"/>
               </a:rPr>
               <a:t>Complejidad</a:t>
             </a:r>
@@ -3789,9 +3479,9 @@
                 <a:solidFill>
                   <a:schemeClr val="tx1"/>
                 </a:solidFill>
-                <a:latin typeface="Cambria" pitchFamily="34" charset="0"/>
-                <a:ea typeface="Cambria" pitchFamily="34" charset="-122"/>
-                <a:cs typeface="Cambria" pitchFamily="34" charset="-120"/>
+                <a:latin typeface="Georgia" pitchFamily="34" charset="0"/>
+                <a:ea typeface="Georgia" pitchFamily="34" charset="-122"/>
+                <a:cs typeface="Georgia" pitchFamily="34" charset="-120"/>
               </a:rPr>
               <a:t>Cuatro agentes, cuatro formas distintas de fallar</a:t>
             </a:r>
@@ -3904,9 +3594,9 @@
                 <a:solidFill>
                   <a:schemeClr val="tx1"/>
                 </a:solidFill>
-                <a:latin typeface="Cambria" pitchFamily="34" charset="0"/>
-                <a:ea typeface="Cambria" pitchFamily="34" charset="-122"/>
-                <a:cs typeface="Cambria" pitchFamily="34" charset="-120"/>
+                <a:latin typeface="Georgia" pitchFamily="34" charset="0"/>
+                <a:ea typeface="Georgia" pitchFamily="34" charset="-122"/>
+                <a:cs typeface="Georgia" pitchFamily="34" charset="-120"/>
               </a:rPr>
               <a:t>1 · Analista</a:t>
             </a:r>
@@ -3921,9 +3611,9 @@
                 <a:solidFill>
                   <a:schemeClr val="tx2"/>
                 </a:solidFill>
-                <a:latin typeface="Calibri" pitchFamily="34" charset="0"/>
-                <a:ea typeface="Calibri" pitchFamily="34" charset="-122"/>
-                <a:cs typeface="Calibri" pitchFamily="34" charset="-120"/>
+                <a:latin typeface="Arial" pitchFamily="34" charset="0"/>
+                <a:ea typeface="Arial" pitchFamily="34" charset="-122"/>
+                <a:cs typeface="Arial" pitchFamily="34" charset="-120"/>
               </a:rPr>
               <a:t>qwen3.8-27b · 6 tools</a:t>
             </a:r>
@@ -3960,9 +3650,9 @@
                 <a:solidFill>
                   <a:schemeClr val="tx1"/>
                 </a:solidFill>
-                <a:latin typeface="Calibri" pitchFamily="34" charset="0"/>
-                <a:ea typeface="Calibri" pitchFamily="34" charset="-122"/>
-                <a:cs typeface="Calibri" pitchFamily="34" charset="-120"/>
+                <a:latin typeface="Arial" pitchFamily="34" charset="0"/>
+                <a:ea typeface="Arial" pitchFamily="34" charset="-122"/>
+                <a:cs typeface="Arial" pitchFamily="34" charset="-120"/>
               </a:rPr>
               <a:t>Traduce el prompt en cambios validados en el estado.</a:t>
             </a:r>
@@ -3999,9 +3689,9 @@
                 <a:solidFill>
                   <a:schemeClr val="tx2"/>
                 </a:solidFill>
-                <a:latin typeface="Calibri" pitchFamily="34" charset="0"/>
-                <a:ea typeface="Calibri" pitchFamily="34" charset="-122"/>
-                <a:cs typeface="Calibri" pitchFamily="34" charset="-120"/>
+                <a:latin typeface="Arial" pitchFamily="34" charset="0"/>
+                <a:ea typeface="Arial" pitchFamily="34" charset="-122"/>
+                <a:cs typeface="Arial" pitchFamily="34" charset="-120"/>
               </a:rPr>
               <a:t>Inventar datos → tools que validan</a:t>
             </a:r>
@@ -4114,9 +3804,9 @@
                 <a:solidFill>
                   <a:schemeClr val="tx1"/>
                 </a:solidFill>
-                <a:latin typeface="Cambria" pitchFamily="34" charset="0"/>
-                <a:ea typeface="Cambria" pitchFamily="34" charset="-122"/>
-                <a:cs typeface="Cambria" pitchFamily="34" charset="-120"/>
+                <a:latin typeface="Georgia" pitchFamily="34" charset="0"/>
+                <a:ea typeface="Georgia" pitchFamily="34" charset="-122"/>
+                <a:cs typeface="Georgia" pitchFamily="34" charset="-120"/>
               </a:rPr>
               <a:t>2 · Planificador</a:t>
             </a:r>
@@ -4131,9 +3821,9 @@
                 <a:solidFill>
                   <a:schemeClr val="tx2"/>
                 </a:solidFill>
-                <a:latin typeface="Calibri" pitchFamily="34" charset="0"/>
-                <a:ea typeface="Calibri" pitchFamily="34" charset="-122"/>
-                <a:cs typeface="Calibri" pitchFamily="34" charset="-120"/>
+                <a:latin typeface="Arial" pitchFamily="34" charset="0"/>
+                <a:ea typeface="Arial" pitchFamily="34" charset="-122"/>
+                <a:cs typeface="Arial" pitchFamily="34" charset="-120"/>
               </a:rPr>
               <a:t>gpt-oss-120b · JSON estricto</a:t>
             </a:r>
@@ -4170,9 +3860,9 @@
                 <a:solidFill>
                   <a:schemeClr val="tx1"/>
                 </a:solidFill>
-                <a:latin typeface="Calibri" pitchFamily="34" charset="0"/>
-                <a:ea typeface="Calibri" pitchFamily="34" charset="-122"/>
-                <a:cs typeface="Calibri" pitchFamily="34" charset="-120"/>
+                <a:latin typeface="Arial" pitchFamily="34" charset="0"/>
+                <a:ea typeface="Arial" pitchFamily="34" charset="-122"/>
+                <a:cs typeface="Arial" pitchFamily="34" charset="-120"/>
               </a:rPr>
               <a:t>Propone 3 estrategias; el código agrega una línea base H.</a:t>
             </a:r>
@@ -4209,9 +3899,9 @@
                 <a:solidFill>
                   <a:schemeClr val="tx2"/>
                 </a:solidFill>
-                <a:latin typeface="Calibri" pitchFamily="34" charset="0"/>
-                <a:ea typeface="Calibri" pitchFamily="34" charset="-122"/>
-                <a:cs typeface="Calibri" pitchFamily="34" charset="-120"/>
+                <a:latin typeface="Arial" pitchFamily="34" charset="0"/>
+                <a:ea typeface="Arial" pitchFamily="34" charset="-122"/>
+                <a:cs typeface="Arial" pitchFamily="34" charset="-120"/>
               </a:rPr>
               <a:t>Variantes cosméticas → 3 lógicas obligatorias</a:t>
             </a:r>
@@ -4324,9 +4014,9 @@
                 <a:solidFill>
                   <a:schemeClr val="tx1"/>
                 </a:solidFill>
-                <a:latin typeface="Cambria" pitchFamily="34" charset="0"/>
-                <a:ea typeface="Cambria" pitchFamily="34" charset="-122"/>
-                <a:cs typeface="Cambria" pitchFamily="34" charset="-120"/>
+                <a:latin typeface="Georgia" pitchFamily="34" charset="0"/>
+                <a:ea typeface="Georgia" pitchFamily="34" charset="-122"/>
+                <a:cs typeface="Georgia" pitchFamily="34" charset="-120"/>
               </a:rPr>
               <a:t>3 · Evaluador</a:t>
             </a:r>
@@ -4341,9 +4031,9 @@
                 <a:solidFill>
                   <a:schemeClr val="tx2"/>
                 </a:solidFill>
-                <a:latin typeface="Calibri" pitchFamily="34" charset="0"/>
-                <a:ea typeface="Calibri" pitchFamily="34" charset="-122"/>
-                <a:cs typeface="Calibri" pitchFamily="34" charset="-120"/>
+                <a:latin typeface="Arial" pitchFamily="34" charset="0"/>
+                <a:ea typeface="Arial" pitchFamily="34" charset="-122"/>
+                <a:cs typeface="Arial" pitchFamily="34" charset="-120"/>
               </a:rPr>
               <a:t>gpt-oss-120b · 2 tools</a:t>
             </a:r>
@@ -4380,9 +4070,9 @@
                 <a:solidFill>
                   <a:schemeClr val="tx1"/>
                 </a:solidFill>
-                <a:latin typeface="Calibri" pitchFamily="34" charset="0"/>
-                <a:ea typeface="Calibri" pitchFamily="34" charset="-122"/>
-                <a:cs typeface="Calibri" pitchFamily="34" charset="-120"/>
+                <a:latin typeface="Arial" pitchFamily="34" charset="0"/>
+                <a:ea typeface="Arial" pitchFamily="34" charset="-122"/>
+                <a:cs typeface="Arial" pitchFamily="34" charset="-120"/>
               </a:rPr>
               <a:t>Simula y compara tiempo, costo, complejidad y riesgo.</a:t>
             </a:r>
@@ -4419,9 +4109,9 @@
                 <a:solidFill>
                   <a:schemeClr val="tx2"/>
                 </a:solidFill>
-                <a:latin typeface="Calibri" pitchFamily="34" charset="0"/>
-                <a:ea typeface="Calibri" pitchFamily="34" charset="-122"/>
-                <a:cs typeface="Calibri" pitchFamily="34" charset="-120"/>
+                <a:latin typeface="Arial" pitchFamily="34" charset="0"/>
+                <a:ea typeface="Arial" pitchFamily="34" charset="-122"/>
+                <a:cs typeface="Arial" pitchFamily="34" charset="-120"/>
               </a:rPr>
               <a:t>Opinar sin medir → simular es obligatorio</a:t>
             </a:r>
@@ -4534,9 +4224,9 @@
                 <a:solidFill>
                   <a:schemeClr val="tx1"/>
                 </a:solidFill>
-                <a:latin typeface="Cambria" pitchFamily="34" charset="0"/>
-                <a:ea typeface="Cambria" pitchFamily="34" charset="-122"/>
-                <a:cs typeface="Cambria" pitchFamily="34" charset="-120"/>
+                <a:latin typeface="Georgia" pitchFamily="34" charset="0"/>
+                <a:ea typeface="Georgia" pitchFamily="34" charset="-122"/>
+                <a:cs typeface="Georgia" pitchFamily="34" charset="-120"/>
               </a:rPr>
               <a:t>4 · Decisor</a:t>
             </a:r>
@@ -4551,9 +4241,9 @@
                 <a:solidFill>
                   <a:schemeClr val="tx2"/>
                 </a:solidFill>
-                <a:latin typeface="Calibri" pitchFamily="34" charset="0"/>
-                <a:ea typeface="Calibri" pitchFamily="34" charset="-122"/>
-                <a:cs typeface="Calibri" pitchFamily="34" charset="-120"/>
+                <a:latin typeface="Arial" pitchFamily="34" charset="0"/>
+                <a:ea typeface="Arial" pitchFamily="34" charset="-122"/>
+                <a:cs typeface="Arial" pitchFamily="34" charset="-120"/>
               </a:rPr>
               <a:t>gpt-oss-120b · JSON estricto</a:t>
             </a:r>
@@ -4590,9 +4280,9 @@
                 <a:solidFill>
                   <a:schemeClr val="tx1"/>
                 </a:solidFill>
-                <a:latin typeface="Calibri" pitchFamily="34" charset="0"/>
-                <a:ea typeface="Calibri" pitchFamily="34" charset="-122"/>
-                <a:cs typeface="Calibri" pitchFamily="34" charset="-120"/>
+                <a:latin typeface="Arial" pitchFamily="34" charset="0"/>
+                <a:ea typeface="Arial" pitchFamily="34" charset="-122"/>
+                <a:cs typeface="Arial" pitchFamily="34" charset="-120"/>
               </a:rPr>
               <a:t>Elige, justifica y deja riesgos y checklist.</a:t>
             </a:r>
@@ -4629,9 +4319,9 @@
                 <a:solidFill>
                   <a:schemeClr val="tx2"/>
                 </a:solidFill>
-                <a:latin typeface="Calibri" pitchFamily="34" charset="0"/>
-                <a:ea typeface="Calibri" pitchFamily="34" charset="-122"/>
-                <a:cs typeface="Calibri" pitchFamily="34" charset="-120"/>
+                <a:latin typeface="Arial" pitchFamily="34" charset="0"/>
+                <a:ea typeface="Arial" pitchFamily="34" charset="-122"/>
+                <a:cs typeface="Arial" pitchFamily="34" charset="-120"/>
               </a:rPr>
               <a:t>Cifras inventadas → auditoría</a:t>
             </a:r>
@@ -4671,9 +4361,9 @@
                 <a:solidFill>
                   <a:schemeClr val="tx1"/>
                 </a:solidFill>
-                <a:latin typeface="Calibri" pitchFamily="34" charset="0"/>
-                <a:ea typeface="Calibri" pitchFamily="34" charset="-122"/>
-                <a:cs typeface="Calibri" pitchFamily="34" charset="-120"/>
+                <a:latin typeface="Arial" pitchFamily="34" charset="0"/>
+                <a:ea typeface="Arial" pitchFamily="34" charset="-122"/>
+                <a:cs typeface="Arial" pitchFamily="34" charset="-120"/>
               </a:rPr>
               <a:t>¿Por qué no 3? </a:t>
             </a:r>
@@ -4688,9 +4378,9 @@
                 <a:solidFill>
                   <a:schemeClr val="tx1"/>
                 </a:solidFill>
-                <a:latin typeface="Calibri" pitchFamily="34" charset="0"/>
-                <a:ea typeface="Calibri" pitchFamily="34" charset="-122"/>
-                <a:cs typeface="Calibri" pitchFamily="34" charset="-120"/>
+                <a:latin typeface="Arial" pitchFamily="34" charset="0"/>
+                <a:ea typeface="Arial" pitchFamily="34" charset="-122"/>
+                <a:cs typeface="Arial" pitchFamily="34" charset="-120"/>
               </a:rPr>
               <a:t>quien propone no debe evaluarse a sí mismo, y quien mide no debe decidir.</a:t>
             </a:r>
@@ -4708,9 +4398,9 @@
                 <a:solidFill>
                   <a:schemeClr val="tx1"/>
                 </a:solidFill>
-                <a:latin typeface="Calibri" pitchFamily="34" charset="0"/>
-                <a:ea typeface="Calibri" pitchFamily="34" charset="-122"/>
-                <a:cs typeface="Calibri" pitchFamily="34" charset="-120"/>
+                <a:latin typeface="Arial" pitchFamily="34" charset="0"/>
+                <a:ea typeface="Arial" pitchFamily="34" charset="-122"/>
+                <a:cs typeface="Arial" pitchFamily="34" charset="-120"/>
               </a:rPr>
               <a:t>¿Por qué no 5? </a:t>
             </a:r>
@@ -4725,9 +4415,9 @@
                 <a:solidFill>
                   <a:schemeClr val="tx1"/>
                 </a:solidFill>
-                <a:latin typeface="Calibri" pitchFamily="34" charset="0"/>
-                <a:ea typeface="Calibri" pitchFamily="34" charset="-122"/>
-                <a:cs typeface="Calibri" pitchFamily="34" charset="-120"/>
+                <a:latin typeface="Arial" pitchFamily="34" charset="0"/>
+                <a:ea typeface="Arial" pitchFamily="34" charset="-122"/>
+                <a:cs typeface="Arial" pitchFamily="34" charset="-120"/>
               </a:rPr>
               <a:t>verificar capacidad y ventanas es cálculo: lo hace un simulador determinista, no otro LLM (exacto, gratis y ahorra ~25% de tokens).</a:t>
             </a:r>
@@ -4836,9 +4526,9 @@
                 <a:solidFill>
                   <a:schemeClr val="tx1"/>
                 </a:solidFill>
-                <a:latin typeface="Cambria" pitchFamily="34" charset="0"/>
-                <a:ea typeface="Cambria" pitchFamily="34" charset="-122"/>
-                <a:cs typeface="Cambria" pitchFamily="34" charset="-120"/>
+                <a:latin typeface="Georgia" pitchFamily="34" charset="0"/>
+                <a:ea typeface="Georgia" pitchFamily="34" charset="-122"/>
+                <a:cs typeface="Georgia" pitchFamily="34" charset="-120"/>
               </a:rPr>
               <a:t>Flujo: secuencial, con un bucle de replanificación</a:t>
             </a:r>
@@ -4924,9 +4614,9 @@
                 <a:solidFill>
                   <a:schemeClr val="bg1"/>
                 </a:solidFill>
-                <a:latin typeface="Calibri" pitchFamily="34" charset="0"/>
-                <a:ea typeface="Calibri" pitchFamily="34" charset="-122"/>
-                <a:cs typeface="Calibri" pitchFamily="34" charset="-120"/>
+                <a:latin typeface="Arial" pitchFamily="34" charset="0"/>
+                <a:ea typeface="Arial" pitchFamily="34" charset="-122"/>
+                <a:cs typeface="Arial" pitchFamily="34" charset="-120"/>
               </a:rPr>
               <a:t>1</a:t>
             </a:r>
@@ -4963,9 +4653,9 @@
                 <a:solidFill>
                   <a:schemeClr val="tx1"/>
                 </a:solidFill>
-                <a:latin typeface="Calibri" pitchFamily="34" charset="0"/>
-                <a:ea typeface="Calibri" pitchFamily="34" charset="-122"/>
-                <a:cs typeface="Calibri" pitchFamily="34" charset="-120"/>
+                <a:latin typeface="Arial" pitchFamily="34" charset="0"/>
+                <a:ea typeface="Arial" pitchFamily="34" charset="-122"/>
+                <a:cs typeface="Arial" pitchFamily="34" charset="-120"/>
               </a:rPr>
               <a:t>Orden</a:t>
             </a:r>
@@ -4980,9 +4670,9 @@
                 <a:solidFill>
                   <a:schemeClr val="tx2"/>
                 </a:solidFill>
-                <a:latin typeface="Calibri" pitchFamily="34" charset="0"/>
-                <a:ea typeface="Calibri" pitchFamily="34" charset="-122"/>
-                <a:cs typeface="Calibri" pitchFamily="34" charset="-120"/>
+                <a:latin typeface="Arial" pitchFamily="34" charset="0"/>
+                <a:ea typeface="Arial" pitchFamily="34" charset="-122"/>
+                <a:cs typeface="Arial" pitchFamily="34" charset="-120"/>
               </a:rPr>
               <a:t>Analista → Planificador → Evaluador → Decisor → coordinador humano.</a:t>
             </a:r>
@@ -5044,9 +4734,9 @@
                 <a:solidFill>
                   <a:schemeClr val="bg1"/>
                 </a:solidFill>
-                <a:latin typeface="Calibri" pitchFamily="34" charset="0"/>
-                <a:ea typeface="Calibri" pitchFamily="34" charset="-122"/>
-                <a:cs typeface="Calibri" pitchFamily="34" charset="-120"/>
+                <a:latin typeface="Arial" pitchFamily="34" charset="0"/>
+                <a:ea typeface="Arial" pitchFamily="34" charset="-122"/>
+                <a:cs typeface="Arial" pitchFamily="34" charset="-120"/>
               </a:rPr>
               <a:t>2</a:t>
             </a:r>
@@ -5083,9 +4773,9 @@
                 <a:solidFill>
                   <a:schemeClr val="tx1"/>
                 </a:solidFill>
-                <a:latin typeface="Calibri" pitchFamily="34" charset="0"/>
-                <a:ea typeface="Calibri" pitchFamily="34" charset="-122"/>
-                <a:cs typeface="Calibri" pitchFamily="34" charset="-120"/>
+                <a:latin typeface="Arial" pitchFamily="34" charset="0"/>
+                <a:ea typeface="Arial" pitchFamily="34" charset="-122"/>
+                <a:cs typeface="Arial" pitchFamily="34" charset="-120"/>
               </a:rPr>
               <a:t>Qué pasa entre agentes</a:t>
             </a:r>
@@ -5100,9 +4790,9 @@
                 <a:solidFill>
                   <a:schemeClr val="tx2"/>
                 </a:solidFill>
-                <a:latin typeface="Calibri" pitchFamily="34" charset="0"/>
-                <a:ea typeface="Calibri" pitchFamily="34" charset="-122"/>
-                <a:cs typeface="Calibri" pitchFamily="34" charset="-120"/>
+                <a:latin typeface="Arial" pitchFamily="34" charset="0"/>
+                <a:ea typeface="Arial" pitchFamily="34" charset="-122"/>
+                <a:cs typeface="Arial" pitchFamily="34" charset="-120"/>
               </a:rPr>
               <a:t>Datos verificados del estado compartido (no copiados de texto), estrategias en JSON y KPIs del simulador.</a:t>
             </a:r>
@@ -5164,9 +4854,9 @@
                 <a:solidFill>
                   <a:schemeClr val="bg1"/>
                 </a:solidFill>
-                <a:latin typeface="Calibri" pitchFamily="34" charset="0"/>
-                <a:ea typeface="Calibri" pitchFamily="34" charset="-122"/>
-                <a:cs typeface="Calibri" pitchFamily="34" charset="-120"/>
+                <a:latin typeface="Arial" pitchFamily="34" charset="0"/>
+                <a:ea typeface="Arial" pitchFamily="34" charset="-122"/>
+                <a:cs typeface="Arial" pitchFamily="34" charset="-120"/>
               </a:rPr>
               <a:t>3</a:t>
             </a:r>
@@ -5203,9 +4893,9 @@
                 <a:solidFill>
                   <a:schemeClr val="tx1"/>
                 </a:solidFill>
-                <a:latin typeface="Calibri" pitchFamily="34" charset="0"/>
-                <a:ea typeface="Calibri" pitchFamily="34" charset="-122"/>
-                <a:cs typeface="Calibri" pitchFamily="34" charset="-120"/>
+                <a:latin typeface="Arial" pitchFamily="34" charset="0"/>
+                <a:ea typeface="Arial" pitchFamily="34" charset="-122"/>
+                <a:cs typeface="Arial" pitchFamily="34" charset="-120"/>
               </a:rPr>
               <a:t>Tipo de flujo</a:t>
             </a:r>
@@ -5220,9 +4910,9 @@
                 <a:solidFill>
                   <a:schemeClr val="tx2"/>
                 </a:solidFill>
-                <a:latin typeface="Calibri" pitchFamily="34" charset="0"/>
-                <a:ea typeface="Calibri" pitchFamily="34" charset="-122"/>
-                <a:cs typeface="Calibri" pitchFamily="34" charset="-120"/>
+                <a:latin typeface="Arial" pitchFamily="34" charset="0"/>
+                <a:ea typeface="Arial" pitchFamily="34" charset="-122"/>
+                <a:cs typeface="Arial" pitchFamily="34" charset="-120"/>
               </a:rPr>
               <a:t>Secuencial con bucle condicional: si ninguna estrategia es factible, vuelve al Planificador una sola vez con las violaciones exactas.</a:t>
             </a:r>
@@ -5284,9 +4974,9 @@
                 <a:solidFill>
                   <a:schemeClr val="bg1"/>
                 </a:solidFill>
-                <a:latin typeface="Calibri" pitchFamily="34" charset="0"/>
-                <a:ea typeface="Calibri" pitchFamily="34" charset="-122"/>
-                <a:cs typeface="Calibri" pitchFamily="34" charset="-120"/>
+                <a:latin typeface="Arial" pitchFamily="34" charset="0"/>
+                <a:ea typeface="Arial" pitchFamily="34" charset="-122"/>
+                <a:cs typeface="Arial" pitchFamily="34" charset="-120"/>
               </a:rPr>
               <a:t>4</a:t>
             </a:r>
@@ -5323,9 +5013,9 @@
                 <a:solidFill>
                   <a:schemeClr val="tx1"/>
                 </a:solidFill>
-                <a:latin typeface="Calibri" pitchFamily="34" charset="0"/>
-                <a:ea typeface="Calibri" pitchFamily="34" charset="-122"/>
-                <a:cs typeface="Calibri" pitchFamily="34" charset="-120"/>
+                <a:latin typeface="Arial" pitchFamily="34" charset="0"/>
+                <a:ea typeface="Arial" pitchFamily="34" charset="-122"/>
+                <a:cs typeface="Arial" pitchFamily="34" charset="-120"/>
               </a:rPr>
               <a:t>Quién integra</a:t>
             </a:r>
@@ -5340,9 +5030,9 @@
                 <a:solidFill>
                   <a:schemeClr val="tx2"/>
                 </a:solidFill>
-                <a:latin typeface="Calibri" pitchFamily="34" charset="0"/>
-                <a:ea typeface="Calibri" pitchFamily="34" charset="-122"/>
-                <a:cs typeface="Calibri" pitchFamily="34" charset="-120"/>
+                <a:latin typeface="Arial" pitchFamily="34" charset="0"/>
+                <a:ea typeface="Arial" pitchFamily="34" charset="-122"/>
+                <a:cs typeface="Arial" pitchFamily="34" charset="-120"/>
               </a:rPr>
               <a:t>El Decisor elige y justifica; el orquestador (código) arma las hojas de ruta desde la simulación; el coordinador aprueba.</a:t>
             </a:r>
@@ -5451,11 +5141,11 @@
                 <a:solidFill>
                   <a:schemeClr val="tx1"/>
                 </a:solidFill>
-                <a:latin typeface="Cambria" pitchFamily="34" charset="0"/>
-                <a:ea typeface="Cambria" pitchFamily="34" charset="-122"/>
-                <a:cs typeface="Cambria" pitchFamily="34" charset="-120"/>
-              </a:rPr>
-              <a:t>Groq: 8 tools propias y una demo que no depende de la suerte</a:t>
+                <a:latin typeface="Georgia" pitchFamily="34" charset="0"/>
+                <a:ea typeface="Georgia" pitchFamily="34" charset="-122"/>
+                <a:cs typeface="Georgia" pitchFamily="34" charset="-120"/>
+              </a:rPr>
+              <a:t>Groq: 8 tools propias y una demo sin sorpresas</a:t>
             </a:r>
             <a:endParaRPr lang="en-US" sz="3000" dirty="0"/>
           </a:p>
@@ -5490,9 +5180,9 @@
                 <a:solidFill>
                   <a:schemeClr val="tx1"/>
                 </a:solidFill>
-                <a:latin typeface="Cambria" pitchFamily="34" charset="0"/>
-                <a:ea typeface="Cambria" pitchFamily="34" charset="-122"/>
-                <a:cs typeface="Cambria" pitchFamily="34" charset="-120"/>
+                <a:latin typeface="Georgia" pitchFamily="34" charset="0"/>
+                <a:ea typeface="Georgia" pitchFamily="34" charset="-122"/>
+                <a:cs typeface="Georgia" pitchFamily="34" charset="-120"/>
               </a:rPr>
               <a:t>Tools propias con tool calling nativo</a:t>
             </a:r>
@@ -5529,9 +5219,9 @@
                 <a:solidFill>
                   <a:schemeClr val="accent2"/>
                 </a:solidFill>
-                <a:latin typeface="Calibri" pitchFamily="34" charset="0"/>
-                <a:ea typeface="Calibri" pitchFamily="34" charset="-122"/>
-                <a:cs typeface="Calibri" pitchFamily="34" charset="-120"/>
+                <a:latin typeface="Arial" pitchFamily="34" charset="0"/>
+                <a:ea typeface="Arial" pitchFamily="34" charset="-122"/>
+                <a:cs typeface="Arial" pitchFamily="34" charset="-120"/>
               </a:rPr>
               <a:t>Analista</a:t>
             </a:r>
@@ -5595,9 +5285,9 @@
                 <a:solidFill>
                   <a:schemeClr val="tx1"/>
                 </a:solidFill>
-                <a:latin typeface="Calibri" pitchFamily="34" charset="0"/>
-                <a:ea typeface="Calibri" pitchFamily="34" charset="-122"/>
-                <a:cs typeface="Calibri" pitchFamily="34" charset="-120"/>
+                <a:latin typeface="Arial" pitchFamily="34" charset="0"/>
+                <a:ea typeface="Arial" pitchFamily="34" charset="-122"/>
+                <a:cs typeface="Arial" pitchFamily="34" charset="-120"/>
               </a:rPr>
               <a:t>configurar_operacion</a:t>
             </a:r>
@@ -5661,9 +5351,9 @@
                 <a:solidFill>
                   <a:schemeClr val="tx1"/>
                 </a:solidFill>
-                <a:latin typeface="Calibri" pitchFamily="34" charset="0"/>
-                <a:ea typeface="Calibri" pitchFamily="34" charset="-122"/>
-                <a:cs typeface="Calibri" pitchFamily="34" charset="-120"/>
+                <a:latin typeface="Arial" pitchFamily="34" charset="0"/>
+                <a:ea typeface="Arial" pitchFamily="34" charset="-122"/>
+                <a:cs typeface="Arial" pitchFamily="34" charset="-120"/>
               </a:rPr>
               <a:t>agregar_pedido</a:t>
             </a:r>
@@ -5727,9 +5417,9 @@
                 <a:solidFill>
                   <a:schemeClr val="tx1"/>
                 </a:solidFill>
-                <a:latin typeface="Calibri" pitchFamily="34" charset="0"/>
-                <a:ea typeface="Calibri" pitchFamily="34" charset="-122"/>
-                <a:cs typeface="Calibri" pitchFamily="34" charset="-120"/>
+                <a:latin typeface="Arial" pitchFamily="34" charset="0"/>
+                <a:ea typeface="Arial" pitchFamily="34" charset="-122"/>
+                <a:cs typeface="Arial" pitchFamily="34" charset="-120"/>
               </a:rPr>
               <a:t>modificar_pedido</a:t>
             </a:r>
@@ -5793,9 +5483,9 @@
                 <a:solidFill>
                   <a:schemeClr val="tx1"/>
                 </a:solidFill>
-                <a:latin typeface="Calibri" pitchFamily="34" charset="0"/>
-                <a:ea typeface="Calibri" pitchFamily="34" charset="-122"/>
-                <a:cs typeface="Calibri" pitchFamily="34" charset="-120"/>
+                <a:latin typeface="Arial" pitchFamily="34" charset="0"/>
+                <a:ea typeface="Arial" pitchFamily="34" charset="-122"/>
+                <a:cs typeface="Arial" pitchFamily="34" charset="-120"/>
               </a:rPr>
               <a:t>cancelar_pedido</a:t>
             </a:r>
@@ -5859,9 +5549,9 @@
                 <a:solidFill>
                   <a:schemeClr val="tx1"/>
                 </a:solidFill>
-                <a:latin typeface="Calibri" pitchFamily="34" charset="0"/>
-                <a:ea typeface="Calibri" pitchFamily="34" charset="-122"/>
-                <a:cs typeface="Calibri" pitchFamily="34" charset="-120"/>
+                <a:latin typeface="Arial" pitchFamily="34" charset="0"/>
+                <a:ea typeface="Arial" pitchFamily="34" charset="-122"/>
+                <a:cs typeface="Arial" pitchFamily="34" charset="-120"/>
               </a:rPr>
               <a:t>registrar_restriccion</a:t>
             </a:r>
@@ -5925,9 +5615,9 @@
                 <a:solidFill>
                   <a:schemeClr val="tx1"/>
                 </a:solidFill>
-                <a:latin typeface="Calibri" pitchFamily="34" charset="0"/>
-                <a:ea typeface="Calibri" pitchFamily="34" charset="-122"/>
-                <a:cs typeface="Calibri" pitchFamily="34" charset="-120"/>
+                <a:latin typeface="Arial" pitchFamily="34" charset="0"/>
+                <a:ea typeface="Arial" pitchFamily="34" charset="-122"/>
+                <a:cs typeface="Arial" pitchFamily="34" charset="-120"/>
               </a:rPr>
               <a:t>resumen_operacion</a:t>
             </a:r>
@@ -5964,9 +5654,9 @@
                 <a:solidFill>
                   <a:schemeClr val="accent2"/>
                 </a:solidFill>
-                <a:latin typeface="Calibri" pitchFamily="34" charset="0"/>
-                <a:ea typeface="Calibri" pitchFamily="34" charset="-122"/>
-                <a:cs typeface="Calibri" pitchFamily="34" charset="-120"/>
+                <a:latin typeface="Arial" pitchFamily="34" charset="0"/>
+                <a:ea typeface="Arial" pitchFamily="34" charset="-122"/>
+                <a:cs typeface="Arial" pitchFamily="34" charset="-120"/>
               </a:rPr>
               <a:t>Evaluador</a:t>
             </a:r>
@@ -6030,9 +5720,9 @@
                 <a:solidFill>
                   <a:schemeClr val="tx1"/>
                 </a:solidFill>
-                <a:latin typeface="Calibri" pitchFamily="34" charset="0"/>
-                <a:ea typeface="Calibri" pitchFamily="34" charset="-122"/>
-                <a:cs typeface="Calibri" pitchFamily="34" charset="-120"/>
+                <a:latin typeface="Arial" pitchFamily="34" charset="0"/>
+                <a:ea typeface="Arial" pitchFamily="34" charset="-122"/>
+                <a:cs typeface="Arial" pitchFamily="34" charset="-120"/>
               </a:rPr>
               <a:t>simular_estrategias</a:t>
             </a:r>
@@ -6096,9 +5786,9 @@
                 <a:solidFill>
                   <a:schemeClr val="tx1"/>
                 </a:solidFill>
-                <a:latin typeface="Calibri" pitchFamily="34" charset="0"/>
-                <a:ea typeface="Calibri" pitchFamily="34" charset="-122"/>
-                <a:cs typeface="Calibri" pitchFamily="34" charset="-120"/>
+                <a:latin typeface="Arial" pitchFamily="34" charset="0"/>
+                <a:ea typeface="Arial" pitchFamily="34" charset="-122"/>
+                <a:cs typeface="Arial" pitchFamily="34" charset="-120"/>
               </a:rPr>
               <a:t>prueba_estres</a:t>
             </a:r>
@@ -6135,9 +5825,9 @@
                 <a:solidFill>
                   <a:schemeClr val="tx2"/>
                 </a:solidFill>
-                <a:latin typeface="Calibri" pitchFamily="34" charset="0"/>
-                <a:ea typeface="Calibri" pitchFamily="34" charset="-122"/>
-                <a:cs typeface="Calibri" pitchFamily="34" charset="-120"/>
+                <a:latin typeface="Arial" pitchFamily="34" charset="0"/>
+                <a:ea typeface="Arial" pitchFamily="34" charset="-122"/>
+                <a:cs typeface="Arial" pitchFamily="34" charset="-120"/>
               </a:rPr>
               <a:t>Cada tool valida sus argumentos y responde ok o un error legible, así el agente puede corregir su propia llamada.</a:t>
             </a:r>
@@ -6223,9 +5913,9 @@
                 <a:solidFill>
                   <a:schemeClr val="tx1"/>
                 </a:solidFill>
-                <a:latin typeface="Calibri" pitchFamily="34" charset="0"/>
-                <a:ea typeface="Calibri" pitchFamily="34" charset="-122"/>
-                <a:cs typeface="Calibri" pitchFamily="34" charset="-120"/>
+                <a:latin typeface="Arial" pitchFamily="34" charset="0"/>
+                <a:ea typeface="Arial" pitchFamily="34" charset="-122"/>
+                <a:cs typeface="Arial" pitchFamily="34" charset="-120"/>
               </a:rPr>
               <a:t>Una key por integrante</a:t>
             </a:r>
@@ -6240,9 +5930,9 @@
                 <a:solidFill>
                   <a:schemeClr val="tx2"/>
                 </a:solidFill>
-                <a:latin typeface="Calibri" pitchFamily="34" charset="0"/>
-                <a:ea typeface="Calibri" pitchFamily="34" charset="-122"/>
-                <a:cs typeface="Calibri" pitchFamily="34" charset="-120"/>
+                <a:latin typeface="Arial" pitchFamily="34" charset="0"/>
+                <a:ea typeface="Arial" pitchFamily="34" charset="-122"/>
+                <a:cs typeface="Arial" pitchFamily="34" charset="-120"/>
               </a:rPr>
               <a:t>Se leen del .env y se rotan automáticamente.</a:t>
             </a:r>
@@ -6328,9 +6018,9 @@
                 <a:solidFill>
                   <a:schemeClr val="tx1"/>
                 </a:solidFill>
-                <a:latin typeface="Calibri" pitchFamily="34" charset="0"/>
-                <a:ea typeface="Calibri" pitchFamily="34" charset="-122"/>
-                <a:cs typeface="Calibri" pitchFamily="34" charset="-120"/>
+                <a:latin typeface="Arial" pitchFamily="34" charset="0"/>
+                <a:ea typeface="Arial" pitchFamily="34" charset="-122"/>
+                <a:cs typeface="Arial" pitchFamily="34" charset="-120"/>
               </a:rPr>
               <a:t>Lectura de rate limits</a:t>
             </a:r>
@@ -6345,9 +6035,9 @@
                 <a:solidFill>
                   <a:schemeClr val="tx2"/>
                 </a:solidFill>
-                <a:latin typeface="Calibri" pitchFamily="34" charset="0"/>
-                <a:ea typeface="Calibri" pitchFamily="34" charset="-122"/>
-                <a:cs typeface="Calibri" pitchFamily="34" charset="-120"/>
+                <a:latin typeface="Arial" pitchFamily="34" charset="0"/>
+                <a:ea typeface="Arial" pitchFamily="34" charset="-122"/>
+                <a:cs typeface="Arial" pitchFamily="34" charset="-120"/>
               </a:rPr>
               <a:t>Cabeceras x-ratelimit-* y retry-after: espera o cambia de key.</a:t>
             </a:r>
@@ -6433,9 +6123,9 @@
                 <a:solidFill>
                   <a:schemeClr val="tx1"/>
                 </a:solidFill>
-                <a:latin typeface="Calibri" pitchFamily="34" charset="0"/>
-                <a:ea typeface="Calibri" pitchFamily="34" charset="-122"/>
-                <a:cs typeface="Calibri" pitchFamily="34" charset="-120"/>
+                <a:latin typeface="Arial" pitchFamily="34" charset="0"/>
+                <a:ea typeface="Arial" pitchFamily="34" charset="-122"/>
+                <a:cs typeface="Arial" pitchFamily="34" charset="-120"/>
               </a:rPr>
               <a:t>Modelos de respaldo</a:t>
             </a:r>
@@ -6450,9 +6140,9 @@
                 <a:solidFill>
                   <a:schemeClr val="tx2"/>
                 </a:solidFill>
-                <a:latin typeface="Calibri" pitchFamily="34" charset="0"/>
-                <a:ea typeface="Calibri" pitchFamily="34" charset="-122"/>
-                <a:cs typeface="Calibri" pitchFamily="34" charset="-120"/>
+                <a:latin typeface="Arial" pitchFamily="34" charset="0"/>
+                <a:ea typeface="Arial" pitchFamily="34" charset="-122"/>
+                <a:cs typeface="Arial" pitchFamily="34" charset="-120"/>
               </a:rPr>
               <a:t>Si un modelo no está disponible, el agente pasa al siguiente.</a:t>
             </a:r>
@@ -6538,9 +6228,9 @@
                 <a:solidFill>
                   <a:schemeClr val="tx1"/>
                 </a:solidFill>
-                <a:latin typeface="Calibri" pitchFamily="34" charset="0"/>
-                <a:ea typeface="Calibri" pitchFamily="34" charset="-122"/>
-                <a:cs typeface="Calibri" pitchFamily="34" charset="-120"/>
+                <a:latin typeface="Arial" pitchFamily="34" charset="0"/>
+                <a:ea typeface="Arial" pitchFamily="34" charset="-122"/>
+                <a:cs typeface="Arial" pitchFamily="34" charset="-120"/>
               </a:rPr>
               <a:t>Preflight antes de la demo</a:t>
             </a:r>
@@ -6555,9 +6245,9 @@
                 <a:solidFill>
                   <a:schemeClr val="tx2"/>
                 </a:solidFill>
-                <a:latin typeface="Calibri" pitchFamily="34" charset="0"/>
-                <a:ea typeface="Calibri" pitchFamily="34" charset="-122"/>
-                <a:cs typeface="Calibri" pitchFamily="34" charset="-120"/>
+                <a:latin typeface="Arial" pitchFamily="34" charset="0"/>
+                <a:ea typeface="Arial" pitchFamily="34" charset="-122"/>
+                <a:cs typeface="Arial" pitchFamily="34" charset="-120"/>
               </a:rPr>
               <a:t>Verifica keys, modelos disponibles y cuota restante.</a:t>
             </a:r>
@@ -6621,9 +6311,9 @@
                 <a:solidFill>
                   <a:schemeClr val="accent1"/>
                 </a:solidFill>
-                <a:latin typeface="Cambria" pitchFamily="34" charset="0"/>
-                <a:ea typeface="Cambria" pitchFamily="34" charset="-122"/>
-                <a:cs typeface="Cambria" pitchFamily="34" charset="-120"/>
+                <a:latin typeface="Georgia" pitchFamily="34" charset="0"/>
+                <a:ea typeface="Georgia" pitchFamily="34" charset="-122"/>
+                <a:cs typeface="Georgia" pitchFamily="34" charset="-120"/>
               </a:rPr>
               <a:t>36.1 mil tokens</a:t>
             </a:r>
@@ -6638,9 +6328,9 @@
                 <a:solidFill>
                   <a:schemeClr val="tx2"/>
                 </a:solidFill>
-                <a:latin typeface="Calibri" pitchFamily="34" charset="0"/>
-                <a:ea typeface="Calibri" pitchFamily="34" charset="-122"/>
-                <a:cs typeface="Calibri" pitchFamily="34" charset="-120"/>
+                <a:latin typeface="Arial" pitchFamily="34" charset="0"/>
+                <a:ea typeface="Arial" pitchFamily="34" charset="-122"/>
+                <a:cs typeface="Arial" pitchFamily="34" charset="-120"/>
               </a:rPr>
               <a:t>por corrida completa · 10 llamadas a la API · 2 modelos para repartir la cuota por minuto</a:t>
             </a:r>
@@ -6749,9 +6439,9 @@
                 <a:solidFill>
                   <a:schemeClr val="bg1"/>
                 </a:solidFill>
-                <a:latin typeface="Cambria" pitchFamily="34" charset="0"/>
-                <a:ea typeface="Cambria" pitchFamily="34" charset="-122"/>
-                <a:cs typeface="Cambria" pitchFamily="34" charset="-120"/>
+                <a:latin typeface="Georgia" pitchFamily="34" charset="0"/>
+                <a:ea typeface="Georgia" pitchFamily="34" charset="-122"/>
+                <a:cs typeface="Georgia" pitchFamily="34" charset="-120"/>
               </a:rPr>
               <a:t>Demo en vivo: ustedes dictan el input</a:t>
             </a:r>
@@ -6815,9 +6505,9 @@
                 <a:solidFill>
                   <a:schemeClr val="accent1"/>
                 </a:solidFill>
-                <a:latin typeface="Cambria" pitchFamily="34" charset="0"/>
-                <a:ea typeface="Cambria" pitchFamily="34" charset="-122"/>
-                <a:cs typeface="Cambria" pitchFamily="34" charset="-120"/>
+                <a:latin typeface="Georgia" pitchFamily="34" charset="0"/>
+                <a:ea typeface="Georgia" pitchFamily="34" charset="-122"/>
+                <a:cs typeface="Georgia" pitchFamily="34" charset="-120"/>
               </a:rPr>
               <a:t>1 · pedidos</a:t>
             </a:r>
@@ -6832,9 +6522,9 @@
                 <a:solidFill>
                   <a:schemeClr val="accent6"/>
                 </a:solidFill>
-                <a:latin typeface="Calibri" pitchFamily="34" charset="0"/>
-                <a:ea typeface="Calibri" pitchFamily="34" charset="-122"/>
-                <a:cs typeface="Calibri" pitchFamily="34" charset="-120"/>
+                <a:latin typeface="Arial" pitchFamily="34" charset="0"/>
+                <a:ea typeface="Arial" pitchFamily="34" charset="-122"/>
+                <a:cs typeface="Arial" pitchFamily="34" charset="-120"/>
               </a:rPr>
               <a:t>obligatorio</a:t>
             </a:r>
@@ -6849,9 +6539,9 @@
                 <a:solidFill>
                   <a:schemeClr val="bg1"/>
                 </a:solidFill>
-                <a:latin typeface="Calibri" pitchFamily="34" charset="0"/>
-                <a:ea typeface="Calibri" pitchFamily="34" charset="-122"/>
-                <a:cs typeface="Calibri" pitchFamily="34" charset="-120"/>
+                <a:latin typeface="Arial" pitchFamily="34" charset="0"/>
+                <a:ea typeface="Arial" pitchFamily="34" charset="-122"/>
+                <a:cs typeface="Arial" pitchFamily="34" charset="-120"/>
               </a:rPr>
               <a:t>“Agreguen un urgente de 20 kg de pollo en Lince, 8:30–9:15”</a:t>
             </a:r>
@@ -6915,9 +6605,9 @@
                 <a:solidFill>
                   <a:schemeClr val="accent1"/>
                 </a:solidFill>
-                <a:latin typeface="Cambria" pitchFamily="34" charset="0"/>
-                <a:ea typeface="Cambria" pitchFamily="34" charset="-122"/>
-                <a:cs typeface="Cambria" pitchFamily="34" charset="-120"/>
+                <a:latin typeface="Georgia" pitchFamily="34" charset="0"/>
+                <a:ea typeface="Georgia" pitchFamily="34" charset="-122"/>
+                <a:cs typeface="Georgia" pitchFamily="34" charset="-120"/>
               </a:rPr>
               <a:t>2 · flota</a:t>
             </a:r>
@@ -6932,9 +6622,9 @@
                 <a:solidFill>
                   <a:schemeClr val="accent6"/>
                 </a:solidFill>
-                <a:latin typeface="Calibri" pitchFamily="34" charset="0"/>
-                <a:ea typeface="Calibri" pitchFamily="34" charset="-122"/>
-                <a:cs typeface="Calibri" pitchFamily="34" charset="-120"/>
+                <a:latin typeface="Arial" pitchFamily="34" charset="0"/>
+                <a:ea typeface="Arial" pitchFamily="34" charset="-122"/>
+                <a:cs typeface="Arial" pitchFamily="34" charset="-120"/>
               </a:rPr>
               <a:t>obligatorio</a:t>
             </a:r>
@@ -6949,9 +6639,9 @@
                 <a:solidFill>
                   <a:schemeClr val="bg1"/>
                 </a:solidFill>
-                <a:latin typeface="Calibri" pitchFamily="34" charset="0"/>
-                <a:ea typeface="Calibri" pitchFamily="34" charset="-122"/>
-                <a:cs typeface="Calibri" pitchFamily="34" charset="-120"/>
+                <a:latin typeface="Arial" pitchFamily="34" charset="0"/>
+                <a:ea typeface="Arial" pitchFamily="34" charset="-122"/>
+                <a:cs typeface="Arial" pitchFamily="34" charset="-120"/>
               </a:rPr>
               <a:t>“Hoy se malogró una furgoneta”</a:t>
             </a:r>
@@ -7015,9 +6705,9 @@
                 <a:solidFill>
                   <a:schemeClr val="accent1"/>
                 </a:solidFill>
-                <a:latin typeface="Cambria" pitchFamily="34" charset="0"/>
-                <a:ea typeface="Cambria" pitchFamily="34" charset="-122"/>
-                <a:cs typeface="Cambria" pitchFamily="34" charset="-120"/>
+                <a:latin typeface="Georgia" pitchFamily="34" charset="0"/>
+                <a:ea typeface="Georgia" pitchFamily="34" charset="-122"/>
+                <a:cs typeface="Georgia" pitchFamily="34" charset="-120"/>
               </a:rPr>
               <a:t>3 · horario</a:t>
             </a:r>
@@ -7032,9 +6722,9 @@
                 <a:solidFill>
                   <a:schemeClr val="accent6"/>
                 </a:solidFill>
-                <a:latin typeface="Calibri" pitchFamily="34" charset="0"/>
-                <a:ea typeface="Calibri" pitchFamily="34" charset="-122"/>
-                <a:cs typeface="Calibri" pitchFamily="34" charset="-120"/>
+                <a:latin typeface="Arial" pitchFamily="34" charset="0"/>
+                <a:ea typeface="Arial" pitchFamily="34" charset="-122"/>
+                <a:cs typeface="Arial" pitchFamily="34" charset="-120"/>
               </a:rPr>
               <a:t>opcional</a:t>
             </a:r>
@@ -7049,9 +6739,9 @@
                 <a:solidFill>
                   <a:schemeClr val="bg1"/>
                 </a:solidFill>
-                <a:latin typeface="Calibri" pitchFamily="34" charset="0"/>
-                <a:ea typeface="Calibri" pitchFamily="34" charset="-122"/>
-                <a:cs typeface="Calibri" pitchFamily="34" charset="-120"/>
+                <a:latin typeface="Arial" pitchFamily="34" charset="0"/>
+                <a:ea typeface="Arial" pitchFamily="34" charset="-122"/>
+                <a:cs typeface="Arial" pitchFamily="34" charset="-120"/>
               </a:rPr>
               <a:t>“Salimos a las 8 y volvemos antes de las 2”</a:t>
             </a:r>
@@ -7115,9 +6805,9 @@
                 <a:solidFill>
                   <a:schemeClr val="accent1"/>
                 </a:solidFill>
-                <a:latin typeface="Cambria" pitchFamily="34" charset="0"/>
-                <a:ea typeface="Cambria" pitchFamily="34" charset="-122"/>
-                <a:cs typeface="Cambria" pitchFamily="34" charset="-120"/>
+                <a:latin typeface="Georgia" pitchFamily="34" charset="0"/>
+                <a:ea typeface="Georgia" pitchFamily="34" charset="-122"/>
+                <a:cs typeface="Georgia" pitchFamily="34" charset="-120"/>
               </a:rPr>
               <a:t>4 · restricciones</a:t>
             </a:r>
@@ -7132,9 +6822,9 @@
                 <a:solidFill>
                   <a:schemeClr val="accent6"/>
                 </a:solidFill>
-                <a:latin typeface="Calibri" pitchFamily="34" charset="0"/>
-                <a:ea typeface="Calibri" pitchFamily="34" charset="-122"/>
-                <a:cs typeface="Calibri" pitchFamily="34" charset="-120"/>
+                <a:latin typeface="Arial" pitchFamily="34" charset="0"/>
+                <a:ea typeface="Arial" pitchFamily="34" charset="-122"/>
+                <a:cs typeface="Arial" pitchFamily="34" charset="-120"/>
               </a:rPr>
               <a:t>opcional</a:t>
             </a:r>
@@ -7149,9 +6839,9 @@
                 <a:solidFill>
                   <a:schemeClr val="bg1"/>
                 </a:solidFill>
-                <a:latin typeface="Calibri" pitchFamily="34" charset="0"/>
-                <a:ea typeface="Calibri" pitchFamily="34" charset="-122"/>
-                <a:cs typeface="Calibri" pitchFamily="34" charset="-120"/>
+                <a:latin typeface="Arial" pitchFamily="34" charset="0"/>
+                <a:ea typeface="Arial" pitchFamily="34" charset="-122"/>
+                <a:cs typeface="Arial" pitchFamily="34" charset="-120"/>
               </a:rPr>
               <a:t>“Marcha en el Centro: 50% más lento”</a:t>
             </a:r>
@@ -7215,9 +6905,9 @@
                 <a:solidFill>
                   <a:schemeClr val="accent1"/>
                 </a:solidFill>
-                <a:latin typeface="Cambria" pitchFamily="34" charset="0"/>
-                <a:ea typeface="Cambria" pitchFamily="34" charset="-122"/>
-                <a:cs typeface="Cambria" pitchFamily="34" charset="-120"/>
+                <a:latin typeface="Georgia" pitchFamily="34" charset="0"/>
+                <a:ea typeface="Georgia" pitchFamily="34" charset="-122"/>
+                <a:cs typeface="Georgia" pitchFamily="34" charset="-120"/>
               </a:rPr>
               <a:t>5 · objetivo</a:t>
             </a:r>
@@ -7232,9 +6922,9 @@
                 <a:solidFill>
                   <a:schemeClr val="accent6"/>
                 </a:solidFill>
-                <a:latin typeface="Calibri" pitchFamily="34" charset="0"/>
-                <a:ea typeface="Calibri" pitchFamily="34" charset="-122"/>
-                <a:cs typeface="Calibri" pitchFamily="34" charset="-120"/>
+                <a:latin typeface="Arial" pitchFamily="34" charset="0"/>
+                <a:ea typeface="Arial" pitchFamily="34" charset="-122"/>
+                <a:cs typeface="Arial" pitchFamily="34" charset="-120"/>
               </a:rPr>
               <a:t>opcional</a:t>
             </a:r>
@@ -7249,9 +6939,9 @@
                 <a:solidFill>
                   <a:schemeClr val="bg1"/>
                 </a:solidFill>
-                <a:latin typeface="Calibri" pitchFamily="34" charset="0"/>
-                <a:ea typeface="Calibri" pitchFamily="34" charset="-122"/>
-                <a:cs typeface="Calibri" pitchFamily="34" charset="-120"/>
+                <a:latin typeface="Arial" pitchFamily="34" charset="0"/>
+                <a:ea typeface="Arial" pitchFamily="34" charset="-122"/>
+                <a:cs typeface="Arial" pitchFamily="34" charset="-120"/>
               </a:rPr>
               <a:t>“Hoy importa gastar lo menos posible”</a:t>
             </a:r>
@@ -7337,9 +7027,9 @@
                 <a:solidFill>
                   <a:schemeClr val="bg1"/>
                 </a:solidFill>
-                <a:latin typeface="Calibri" pitchFamily="34" charset="0"/>
-                <a:ea typeface="Calibri" pitchFamily="34" charset="-122"/>
-                <a:cs typeface="Calibri" pitchFamily="34" charset="-120"/>
+                <a:latin typeface="Arial" pitchFamily="34" charset="0"/>
+                <a:ea typeface="Arial" pitchFamily="34" charset="-122"/>
+                <a:cs typeface="Arial" pitchFamily="34" charset="-120"/>
               </a:rPr>
               <a:t>Mientras corre, cada línea con la llave inglesa es una tool que un agente acaba de ejecutar: esa es la evidencia de uso de tools.</a:t>
             </a:r>
@@ -7448,32 +7138,40 @@
                 <a:solidFill>
                   <a:schemeClr val="tx1"/>
                 </a:solidFill>
-                <a:latin typeface="Cambria" pitchFamily="34" charset="0"/>
-                <a:ea typeface="Cambria" pitchFamily="34" charset="-122"/>
-                <a:cs typeface="Cambria" pitchFamily="34" charset="-120"/>
-              </a:rPr>
-              <a:t>Caso base: qué decidió el sistema y cuánto confiar en eso</a:t>
+                <a:latin typeface="Georgia" pitchFamily="34" charset="0"/>
+                <a:ea typeface="Georgia" pitchFamily="34" charset="-122"/>
+                <a:cs typeface="Georgia" pitchFamily="34" charset="-120"/>
+              </a:rPr>
+              <a:t>Caso base: la decisión y cuánto confiar en ella</a:t>
             </a:r>
             <a:endParaRPr lang="en-US" sz="3000" dirty="0"/>
           </a:p>
         </p:txBody>
       </p:sp>
-      <p:graphicFrame>
-        <p:nvGraphicFramePr>
-          <p:cNvPr id="3" name="gráfico puntajes" descr=""/>
-          <p:cNvGraphicFramePr/>
-          <p:nvPr/>
-        </p:nvGraphicFramePr>
-        <p:xfrm>
-          <a:off x="548640" y="1234440"/>
-          <a:ext cx="5760720" cy="3429000"/>
-        </p:xfrm>
-        <a:graphic xmlns:a="http://schemas.openxmlformats.org/drawingml/2006/main">
-          <a:graphicData uri="http://schemas.openxmlformats.org/drawingml/2006/chart">
-            <c:chart xmlns:c="http://schemas.openxmlformats.org/drawingml/2006/chart" r:id="rId1"/>
-          </a:graphicData>
-        </a:graphic>
-      </p:graphicFrame>
+      <p:pic>
+        <p:nvPicPr>
+          <p:cNvPr id="3" name="gráfico puntajes" descr="Puntaje de cada estrategia: A ✗ 46.5, B ✗ 41.3, C 49.2, H (sin LLM) 100">    </p:cNvPr>
+          <p:cNvPicPr>
+            <a:picLocks noChangeAspect="1"/>
+          </p:cNvPicPr>
+          <p:nvPr/>
+        </p:nvPicPr>
+        <p:blipFill>
+          <a:blip r:embed="rId1"/>
+          <a:stretch>
+            <a:fillRect/>
+          </a:stretch>
+        </p:blipFill>
+        <p:spPr>
+          <a:xfrm>
+            <a:off x="548640" y="1234440"/>
+            <a:ext cx="5760720" cy="3429000"/>
+          </a:xfrm>
+          <a:prstGeom prst="rect">
+            <a:avLst/>
+          </a:prstGeom>
+        </p:spPr>
+      </p:pic>
       <p:sp>
         <p:nvSpPr>
           <p:cNvPr id="4" name="decisión"/>
@@ -7530,9 +7228,9 @@
                 <a:solidFill>
                   <a:schemeClr val="tx1"/>
                 </a:solidFill>
-                <a:latin typeface="Calibri" pitchFamily="34" charset="0"/>
-                <a:ea typeface="Calibri" pitchFamily="34" charset="-122"/>
-                <a:cs typeface="Calibri" pitchFamily="34" charset="-120"/>
+                <a:latin typeface="Arial" pitchFamily="34" charset="0"/>
+                <a:ea typeface="Arial" pitchFamily="34" charset="-122"/>
+                <a:cs typeface="Arial" pitchFamily="34" charset="-120"/>
               </a:rPr>
               <a:t>Elegida: H · Línea base: heurística voraz sin LLM</a:t>
             </a:r>
@@ -7547,9 +7245,9 @@
                 <a:solidFill>
                   <a:schemeClr val="tx2"/>
                 </a:solidFill>
-                <a:latin typeface="Calibri" pitchFamily="34" charset="0"/>
-                <a:ea typeface="Calibri" pitchFamily="34" charset="-122"/>
-                <a:cs typeface="Calibri" pitchFamily="34" charset="-120"/>
+                <a:latin typeface="Arial" pitchFamily="34" charset="0"/>
+                <a:ea typeface="Arial" pitchFamily="34" charset="-122"/>
+                <a:cs typeface="Arial" pitchFamily="34" charset="-120"/>
               </a:rPr>
               <a:t>S/ 356.1 · 100% a tiempo · urgentes 6/6 · regreso 12:14</a:t>
             </a:r>
@@ -7635,9 +7333,9 @@
                 <a:solidFill>
                   <a:schemeClr val="tx1"/>
                 </a:solidFill>
-                <a:latin typeface="Calibri" pitchFamily="34" charset="0"/>
-                <a:ea typeface="Calibri" pitchFamily="34" charset="-122"/>
-                <a:cs typeface="Calibri" pitchFamily="34" charset="-120"/>
+                <a:latin typeface="Arial" pitchFamily="34" charset="0"/>
+                <a:ea typeface="Arial" pitchFamily="34" charset="-122"/>
+                <a:cs typeface="Arial" pitchFamily="34" charset="-120"/>
               </a:rPr>
               <a:t>Agentes vs. línea base H (sin LLM)</a:t>
             </a:r>
@@ -7652,9 +7350,9 @@
                 <a:solidFill>
                   <a:schemeClr val="tx2"/>
                 </a:solidFill>
-                <a:latin typeface="Calibri" pitchFamily="34" charset="0"/>
-                <a:ea typeface="Calibri" pitchFamily="34" charset="-122"/>
-                <a:cs typeface="Calibri" pitchFamily="34" charset="-120"/>
+                <a:latin typeface="Arial" pitchFamily="34" charset="0"/>
+                <a:ea typeface="Arial" pitchFamily="34" charset="-122"/>
+                <a:cs typeface="Arial" pitchFamily="34" charset="-120"/>
               </a:rPr>
               <a:t>Mejor propuesta de los agentes 49.2 vs H 100 puntos. Gana la regla simple: H funciona como red de seguridad.</a:t>
             </a:r>
@@ -7740,9 +7438,9 @@
                 <a:solidFill>
                   <a:schemeClr val="tx1"/>
                 </a:solidFill>
-                <a:latin typeface="Calibri" pitchFamily="34" charset="0"/>
-                <a:ea typeface="Calibri" pitchFamily="34" charset="-122"/>
-                <a:cs typeface="Calibri" pitchFamily="34" charset="-120"/>
+                <a:latin typeface="Arial" pitchFamily="34" charset="0"/>
+                <a:ea typeface="Arial" pitchFamily="34" charset="-122"/>
+                <a:cs typeface="Arial" pitchFamily="34" charset="-120"/>
               </a:rPr>
               <a:t>Auditoría automática</a:t>
             </a:r>
@@ -7757,9 +7455,9 @@
                 <a:solidFill>
                   <a:schemeClr val="tx2"/>
                 </a:solidFill>
-                <a:latin typeface="Calibri" pitchFamily="34" charset="0"/>
-                <a:ea typeface="Calibri" pitchFamily="34" charset="-122"/>
-                <a:cs typeface="Calibri" pitchFamily="34" charset="-120"/>
+                <a:latin typeface="Arial" pitchFamily="34" charset="0"/>
+                <a:ea typeface="Arial" pitchFamily="34" charset="-122"/>
+                <a:cs typeface="Arial" pitchFamily="34" charset="-120"/>
               </a:rPr>
               <a:t>10 de 11 verificaciones OK; 0 críticas fallidas. Revisa que las cifras citadas existan en el simulador.</a:t>
             </a:r>
@@ -7845,9 +7543,9 @@
                 <a:solidFill>
                   <a:schemeClr val="tx1"/>
                 </a:solidFill>
-                <a:latin typeface="Calibri" pitchFamily="34" charset="0"/>
-                <a:ea typeface="Calibri" pitchFamily="34" charset="-122"/>
-                <a:cs typeface="Calibri" pitchFamily="34" charset="-120"/>
+                <a:latin typeface="Arial" pitchFamily="34" charset="0"/>
+                <a:ea typeface="Arial" pitchFamily="34" charset="-122"/>
+                <a:cs typeface="Arial" pitchFamily="34" charset="-120"/>
               </a:rPr>
               <a:t>Datos incorrectos</a:t>
             </a:r>
@@ -7862,9 +7560,9 @@
                 <a:solidFill>
                   <a:schemeClr val="tx2"/>
                 </a:solidFill>
-                <a:latin typeface="Calibri" pitchFamily="34" charset="0"/>
-                <a:ea typeface="Calibri" pitchFamily="34" charset="-122"/>
-                <a:cs typeface="Calibri" pitchFamily="34" charset="-120"/>
+                <a:latin typeface="Arial" pitchFamily="34" charset="0"/>
+                <a:ea typeface="Arial" pitchFamily="34" charset="-122"/>
+                <a:cs typeface="Arial" pitchFamily="34" charset="-120"/>
               </a:rPr>
               <a:t>Los errores de formato se rechazan. Un error plausible (150 kg en vez de 15) pasa: por eso revisa una persona.</a:t>
             </a:r>
@@ -7950,9 +7648,9 @@
                 <a:solidFill>
                   <a:schemeClr val="tx1"/>
                 </a:solidFill>
-                <a:latin typeface="Calibri" pitchFamily="34" charset="0"/>
-                <a:ea typeface="Calibri" pitchFamily="34" charset="-122"/>
-                <a:cs typeface="Calibri" pitchFamily="34" charset="-120"/>
+                <a:latin typeface="Arial" pitchFamily="34" charset="0"/>
+                <a:ea typeface="Arial" pitchFamily="34" charset="-122"/>
+                <a:cs typeface="Arial" pitchFamily="34" charset="-120"/>
               </a:rPr>
               <a:t>Flota insuficiente</a:t>
             </a:r>
@@ -7967,9 +7665,9 @@
                 <a:solidFill>
                   <a:schemeClr val="tx2"/>
                 </a:solidFill>
-                <a:latin typeface="Calibri" pitchFamily="34" charset="0"/>
-                <a:ea typeface="Calibri" pitchFamily="34" charset="-122"/>
-                <a:cs typeface="Calibri" pitchFamily="34" charset="-120"/>
+                <a:latin typeface="Arial" pitchFamily="34" charset="0"/>
+                <a:ea typeface="Arial" pitchFamily="34" charset="-122"/>
+                <a:cs typeface="Arial" pitchFamily="34" charset="-120"/>
               </a:rPr>
               <a:t>1 replanificación(es); la auditoría marcó 4 problemas (incluidos errores del Decisor) y escaló a una persona.</a:t>
             </a:r>
@@ -8078,9 +7776,9 @@
                 <a:solidFill>
                   <a:schemeClr val="bg1"/>
                 </a:solidFill>
-                <a:latin typeface="Cambria" pitchFamily="34" charset="0"/>
-                <a:ea typeface="Cambria" pitchFamily="34" charset="-122"/>
-                <a:cs typeface="Cambria" pitchFamily="34" charset="-120"/>
+                <a:latin typeface="Georgia" pitchFamily="34" charset="0"/>
+                <a:ea typeface="Georgia" pitchFamily="34" charset="-122"/>
+                <a:cs typeface="Georgia" pitchFamily="34" charset="-120"/>
               </a:rPr>
               <a:t>Lo que el sistema no decide solo</a:t>
             </a:r>
@@ -8166,9 +7864,9 @@
                 <a:solidFill>
                   <a:schemeClr val="bg1"/>
                 </a:solidFill>
-                <a:latin typeface="Cambria" pitchFamily="34" charset="0"/>
-                <a:ea typeface="Cambria" pitchFamily="34" charset="-122"/>
-                <a:cs typeface="Cambria" pitchFamily="34" charset="-120"/>
+                <a:latin typeface="Georgia" pitchFamily="34" charset="0"/>
+                <a:ea typeface="Georgia" pitchFamily="34" charset="-122"/>
+                <a:cs typeface="Georgia" pitchFamily="34" charset="-120"/>
               </a:rPr>
               <a:t>Dónde interviene una persona</a:t>
             </a:r>
@@ -8209,9 +7907,9 @@
                 <a:solidFill>
                   <a:schemeClr val="bg1"/>
                 </a:solidFill>
-                <a:latin typeface="Calibri" pitchFamily="34" charset="0"/>
-                <a:ea typeface="Calibri" pitchFamily="34" charset="-122"/>
-                <a:cs typeface="Calibri" pitchFamily="34" charset="-120"/>
+                <a:latin typeface="Arial" pitchFamily="34" charset="0"/>
+                <a:ea typeface="Arial" pitchFamily="34" charset="-122"/>
+                <a:cs typeface="Arial" pitchFamily="34" charset="-120"/>
               </a:rPr>
               <a:t>Confirma los cambios que interpretó el Analista</a:t>
             </a:r>
@@ -8230,9 +7928,9 @@
                 <a:solidFill>
                   <a:schemeClr val="bg1"/>
                 </a:solidFill>
-                <a:latin typeface="Calibri" pitchFamily="34" charset="0"/>
-                <a:ea typeface="Calibri" pitchFamily="34" charset="-122"/>
-                <a:cs typeface="Calibri" pitchFamily="34" charset="-120"/>
+                <a:latin typeface="Arial" pitchFamily="34" charset="0"/>
+                <a:ea typeface="Arial" pitchFamily="34" charset="-122"/>
+                <a:cs typeface="Arial" pitchFamily="34" charset="-120"/>
               </a:rPr>
               <a:t>Hace el checklist antes de despachar</a:t>
             </a:r>
@@ -8251,9 +7949,9 @@
                 <a:solidFill>
                   <a:schemeClr val="bg1"/>
                 </a:solidFill>
-                <a:latin typeface="Calibri" pitchFamily="34" charset="0"/>
-                <a:ea typeface="Calibri" pitchFamily="34" charset="-122"/>
-                <a:cs typeface="Calibri" pitchFamily="34" charset="-120"/>
+                <a:latin typeface="Arial" pitchFamily="34" charset="0"/>
+                <a:ea typeface="Arial" pitchFamily="34" charset="-122"/>
+                <a:cs typeface="Arial" pitchFamily="34" charset="-120"/>
               </a:rPr>
               <a:t>Decide en cualquier escalamiento (subcontratar, renegociar)</a:t>
             </a:r>
@@ -8272,9 +7970,9 @@
                 <a:solidFill>
                   <a:schemeClr val="bg1"/>
                 </a:solidFill>
-                <a:latin typeface="Calibri" pitchFamily="34" charset="0"/>
-                <a:ea typeface="Calibri" pitchFamily="34" charset="-122"/>
-                <a:cs typeface="Calibri" pitchFamily="34" charset="-120"/>
+                <a:latin typeface="Arial" pitchFamily="34" charset="0"/>
+                <a:ea typeface="Arial" pitchFamily="34" charset="-122"/>
+                <a:cs typeface="Arial" pitchFamily="34" charset="-120"/>
               </a:rPr>
               <a:t>Aprueba o rechaza el plan final</a:t>
             </a:r>
@@ -8360,9 +8058,9 @@
                 <a:solidFill>
                   <a:schemeClr val="bg1"/>
                 </a:solidFill>
-                <a:latin typeface="Cambria" pitchFamily="34" charset="0"/>
-                <a:ea typeface="Cambria" pitchFamily="34" charset="-122"/>
-                <a:cs typeface="Cambria" pitchFamily="34" charset="-120"/>
+                <a:latin typeface="Georgia" pitchFamily="34" charset="0"/>
+                <a:ea typeface="Georgia" pitchFamily="34" charset="-122"/>
+                <a:cs typeface="Georgia" pitchFamily="34" charset="-120"/>
               </a:rPr>
               <a:t>Siguiente versión</a:t>
             </a:r>
@@ -8403,9 +8101,9 @@
                 <a:solidFill>
                   <a:schemeClr val="bg1"/>
                 </a:solidFill>
-                <a:latin typeface="Calibri" pitchFamily="34" charset="0"/>
-                <a:ea typeface="Calibri" pitchFamily="34" charset="-122"/>
-                <a:cs typeface="Calibri" pitchFamily="34" charset="-120"/>
+                <a:latin typeface="Arial" pitchFamily="34" charset="0"/>
+                <a:ea typeface="Arial" pitchFamily="34" charset="-122"/>
+                <a:cs typeface="Arial" pitchFamily="34" charset="-120"/>
               </a:rPr>
               <a:t>Tiempos reales con una API de rutas y tráfico</a:t>
             </a:r>
@@ -8424,9 +8122,9 @@
                 <a:solidFill>
                   <a:schemeClr val="bg1"/>
                 </a:solidFill>
-                <a:latin typeface="Calibri" pitchFamily="34" charset="0"/>
-                <a:ea typeface="Calibri" pitchFamily="34" charset="-122"/>
-                <a:cs typeface="Calibri" pitchFamily="34" charset="-120"/>
+                <a:latin typeface="Arial" pitchFamily="34" charset="0"/>
+                <a:ea typeface="Arial" pitchFamily="34" charset="-122"/>
+                <a:cs typeface="Arial" pitchFamily="34" charset="-120"/>
               </a:rPr>
               <a:t>OR-Tools (VRPTW) como tool del Planificador</a:t>
             </a:r>
@@ -8445,9 +8143,9 @@
                 <a:solidFill>
                   <a:schemeClr val="bg1"/>
                 </a:solidFill>
-                <a:latin typeface="Calibri" pitchFamily="34" charset="0"/>
-                <a:ea typeface="Calibri" pitchFamily="34" charset="-122"/>
-                <a:cs typeface="Calibri" pitchFamily="34" charset="-120"/>
+                <a:latin typeface="Arial" pitchFamily="34" charset="0"/>
+                <a:ea typeface="Arial" pitchFamily="34" charset="-122"/>
+                <a:cs typeface="Arial" pitchFamily="34" charset="-120"/>
               </a:rPr>
               <a:t>Validar contra el histórico de cada cliente</a:t>
             </a:r>
@@ -8466,9 +8164,9 @@
                 <a:solidFill>
                   <a:schemeClr val="bg1"/>
                 </a:solidFill>
-                <a:latin typeface="Calibri" pitchFamily="34" charset="0"/>
-                <a:ea typeface="Calibri" pitchFamily="34" charset="-122"/>
-                <a:cs typeface="Calibri" pitchFamily="34" charset="-120"/>
+                <a:latin typeface="Arial" pitchFamily="34" charset="0"/>
+                <a:ea typeface="Arial" pitchFamily="34" charset="-122"/>
+                <a:cs typeface="Arial" pitchFamily="34" charset="-120"/>
               </a:rPr>
               <a:t>Varias corridas y voto para medir estabilidad</a:t>
             </a:r>
@@ -8505,9 +8203,9 @@
                 <a:solidFill>
                   <a:schemeClr val="accent1"/>
                 </a:solidFill>
-                <a:latin typeface="Cambria" pitchFamily="34" charset="0"/>
-                <a:ea typeface="Cambria" pitchFamily="34" charset="-122"/>
-                <a:cs typeface="Cambria" pitchFamily="34" charset="-120"/>
+                <a:latin typeface="Georgia" pitchFamily="34" charset="0"/>
+                <a:ea typeface="Georgia" pitchFamily="34" charset="-122"/>
+                <a:cs typeface="Georgia" pitchFamily="34" charset="-120"/>
               </a:rPr>
               <a:t>El LLM interpreta y juzga; el código calcula y verifica; la persona decide.</a:t>
             </a:r>
@@ -8522,9 +8220,9 @@
                 <a:solidFill>
                   <a:schemeClr val="accent6"/>
                 </a:solidFill>
-                <a:latin typeface="Calibri" pitchFamily="34" charset="0"/>
-                <a:ea typeface="Calibri" pitchFamily="34" charset="-122"/>
-                <a:cs typeface="Calibri" pitchFamily="34" charset="-120"/>
+                <a:latin typeface="Arial" pitchFamily="34" charset="0"/>
+                <a:ea typeface="Arial" pitchFamily="34" charset="-122"/>
+                <a:cs typeface="Arial" pitchFamily="34" charset="-120"/>
               </a:rPr>
               <a:t>Gracias · ¿Preguntas?</a:t>
             </a:r>
@@ -8628,7 +8326,7 @@
     </a:clrScheme>
     <a:fontScheme name="RutaBrasa">
       <a:majorFont>
-        <a:latin typeface="Cambria"/>
+        <a:latin typeface="Georgia"/>
         <a:ea typeface=""/>
         <a:cs typeface=""/>
         <a:font script="Jpan" typeface="游ゴシック Light"/>
@@ -8680,7 +8378,7 @@
         <a:font script="Tfng" typeface="Ebrima"/>
       </a:majorFont>
       <a:minorFont>
-        <a:latin typeface="Calibri"/>
+        <a:latin typeface="Arial"/>
         <a:ea typeface=""/>
         <a:cs typeface=""/>
         <a:font script="Jpan" typeface="游ゴシック"/>

</xml_diff>